<commit_message>
Publish complete example model results and quieter demo notices
</commit_message>
<xml_diff>
--- a/site/showcase/exports/earth_image.pptx
+++ b/site/showcase/exports/earth_image.pptx
@@ -21,7 +21,6 @@
     <p:sldId id="269" r:id="rId21"/>
     <p:sldId id="270" r:id="rId22"/>
     <p:sldId id="271" r:id="rId23"/>
-    <p:sldId id="272" r:id="rId24"/>
   </p:sldIdLst>
   <p:sldSz cx="9144000" cy="6858000" type="screen4x3"/>
   <p:notesSz cx="6858000" cy="9144000"/>
@@ -993,17 +992,17 @@
           </a:p>
           <a:p>
             <a:r>
-              <a:t>Claude Vision | synthetic likelihood 5/100; tells: composition matches the widely circulated 1972 Apollo 17 'Blue Marble' photograph (AS17-148-22727), geographically accurate Africa, Arabian Peninsula, Red Sea, Gulf of Aden and Madagascar outlines, Antarctic ice cap consistent with December solstice illumination, physically coherent cloud structures: cyclonic swirls, frontal bands, open-cell cumulus fields</a:t>
-            </a:r>
-          </a:p>
-          <a:p>
-            <a:r>
-              <a:t>OpenAI Vision | synthetic likelihood 2/100; tells: Coherent coastlines of Africa, Madagascar and the Arabian Peninsula, Irregular, finely detailed cloud systems with consistent spherical foreshortening, Natural atmospheric haze and gradual shading around Earth's limb, Fine photographic grain and slight color fringing along the globe edge</a:t>
-            </a:r>
-          </a:p>
-          <a:p>
-            <a:r>
-              <a:t>Gemini Vision | synthetic likelihood 15/100; tells: authentic Apollo 17 'Blue Marble' photograph, natural film grain structure, consistent atmospheric limb glow, accurate meteorological cloud swirls</a:t>
+              <a:t>Claude Vision | synthetic likelihood 4/100; tells: visually consistent with the widely documented Apollo 17 'Blue Marble' photograph (NASA AS17-148-22727, Dec 1972), geographically accurate coastlines: Africa, Arabian Peninsula, Red Sea, Gulf of Aden, Madagascar, Antarctic ice cap, physically coherent cloud systems and cyclonic swirls with plausible meteorological structure, film-scan grain and slight color cast consistent with analog photography</a:t>
+            </a:r>
+          </a:p>
+          <a:p>
+            <a:r>
+              <a:t>OpenAI Vision | synthetic likelihood 2/100; tells: Coherent African, Arabian Peninsula, and Madagascar coastlines, Intricate, nonrepeating cloud bands and storm spirals, Consistent atmospheric haze and foreshortening toward Earth's limb, Fine grain and slight softness consistent with a scanned photograph</a:t>
+            </a:r>
+          </a:p>
+          <a:p>
+            <a:r>
+              <a:t>Gemini Vision | synthetic likelihood 25/100; tells: authentic film grain, consistent atmospheric limb scatter, historically documented cloud formations, natural optical sensor characteristics</a:t>
             </a:r>
           </a:p>
         </p:txBody>
@@ -1263,12 +1262,12 @@
           </a:p>
           <a:p>
             <a:r>
-              <a:t>Analysis ID | b8bb2ceb-20cc-4afd-a616-7cbaace7f08a</a:t>
-            </a:r>
-          </a:p>
-          <a:p>
-            <a:r>
-              <a:t>Generated | 2026-09-26T17:54:47+00:00</a:t>
+              <a:t>Analysis ID | afa06964-dc8c-4c81-8fc7-b6179d9b2705</a:t>
+            </a:r>
+          </a:p>
+          <a:p>
+            <a:r>
+              <a:t>Generated | 2026-09-26T22:31:03+00:00</a:t>
             </a:r>
           </a:p>
           <a:p>
@@ -1283,7 +1282,7 @@
           </a:p>
           <a:p>
             <a:r>
-              <a:t>Method version | verdict-consistency-2026-09-26.1</a:t>
+              <a:t>Method version | pdf-preparation-2026-09-26.1</a:t>
             </a:r>
           </a:p>
           <a:p>
@@ -1298,147 +1297,12 @@
           </a:p>
           <a:p>
             <a:r>
-              <a:t>Ingestion note 1 | Recomputed locally from the same saved provider replies acquired under run five-examples-20260926-r1. No new provider requests. Original report 6201ac7a-3540-405f-b234-0346b77f7672 was generated at 2026-09-26T17:38:41+00:00 under method publication-repair-2026-09-24.3; that report is preserved.</a:t>
-            </a:r>
-          </a:p>
-          <a:p>
-            <a:r>
-              <a:t>Ingestion note 2 | Method verdict-consistency-2026-09-26.1: directional model votes require matching explicit verdicts and rating thresholds. Inconclusive replies retain their ratings and remain undecided observations.</a:t>
-            </a:r>
-          </a:p>
-          <a:p>
-            <a:r>
-              <a:t>Ingestion note 3 | Presentation copy of saved report cf784e2f-0554-4bed-8880-c825ae7b8282. The descriptive filename replaces the earlier example ID for navigation. Original analysis dates, provider replies, scores and acquisition context are retained; no new model analysis.</a:t>
-            </a:r>
-          </a:p>
-        </p:txBody>
-      </p:sp>
-      <p:sp>
-        <p:nvSpPr>
-          <p:cNvPr id="4" name="Slide Number Placeholder 3"/>
-          <p:cNvSpPr>
-            <a:spLocks noGrp="1"/>
-          </p:cNvSpPr>
-          <p:nvPr>
-            <p:ph type="sldNum" idx="5" sz="quarter"/>
-          </p:nvPr>
-        </p:nvSpPr>
-        <p:spPr/>
-      </p:sp>
-    </p:spTree>
-  </p:cSld>
-  <p:clrMapOvr>
-    <a:masterClrMapping/>
-  </p:clrMapOvr>
-</p:notes>
-</file>
-
-<file path=ppt/notesSlides/notesSlide17.xml><?xml version="1.0" encoding="utf-8"?>
-<p:notes xmlns:a="http://schemas.openxmlformats.org/drawingml/2006/main" xmlns:p="http://schemas.openxmlformats.org/presentationml/2006/main" xmlns:r="http://schemas.openxmlformats.org/officeDocument/2006/relationships">
-  <p:cSld>
-    <p:spTree>
-      <p:nvGrpSpPr>
-        <p:cNvPr id="1" name=""/>
-        <p:cNvGrpSpPr/>
-        <p:nvPr/>
-      </p:nvGrpSpPr>
-      <p:grpSpPr>
-        <a:xfrm>
-          <a:off x="0" y="0"/>
-          <a:ext cx="0" cy="0"/>
-          <a:chOff x="0" y="0"/>
-          <a:chExt cx="0" cy="0"/>
-        </a:xfrm>
-      </p:grpSpPr>
-      <p:sp>
-        <p:nvSpPr>
-          <p:cNvPr id="2" name="Slide Image Placeholder 1"/>
-          <p:cNvSpPr>
-            <a:spLocks noGrp="1"/>
-          </p:cNvSpPr>
-          <p:nvPr>
-            <p:ph type="sldImg" idx="2"/>
-          </p:nvPr>
-        </p:nvSpPr>
-        <p:spPr/>
-      </p:sp>
-      <p:sp>
-        <p:nvSpPr>
-          <p:cNvPr id="3" name="Notes Placeholder 2"/>
-          <p:cNvSpPr>
-            <a:spLocks noGrp="1"/>
-          </p:cNvSpPr>
-          <p:nvPr>
-            <p:ph type="body" idx="3" sz="quarter"/>
-          </p:nvPr>
-        </p:nvSpPr>
-        <p:spPr/>
-        <p:txBody>
-          <a:bodyPr/>
-          <a:lstStyle/>
-          <a:p>
-            <a:r>
-              <a:t>earth-image.jpg</a:t>
-            </a:r>
-          </a:p>
-          <a:p>
-            <a:r>
-              <a:t>File and analysis record</a:t>
-            </a:r>
-          </a:p>
-          <a:p>
-            <a:r>
-              <a:t>File | earth-image.jpg</a:t>
-            </a:r>
-          </a:p>
-          <a:p>
-            <a:r>
-              <a:t>Analysis ID | b8bb2ceb-20cc-4afd-a616-7cbaace7f08a</a:t>
-            </a:r>
-          </a:p>
-          <a:p>
-            <a:r>
-              <a:t>Generated | 2026-09-26T17:54:47+00:00</a:t>
-            </a:r>
-          </a:p>
-          <a:p>
-            <a:r>
-              <a:t>Tool | SDA Vision 0.1.0</a:t>
-            </a:r>
-          </a:p>
-          <a:p>
-            <a:r>
-              <a:t>Models | claude-opus-5-5, gemini-3.8-flash, gpt-6-astra</a:t>
-            </a:r>
-          </a:p>
-          <a:p>
-            <a:r>
-              <a:t>Method version | verdict-consistency-2026-09-26.1</a:t>
-            </a:r>
-          </a:p>
-          <a:p>
-            <a:r>
-              <a:t>Analysis lens | general</a:t>
-            </a:r>
-          </a:p>
-          <a:p>
-            <a:r>
-              <a:t>Original SHA-256 | a4bad2aba040fd992aff7483eee6166943e232061b82d7149b2060786719753b</a:t>
-            </a:r>
-          </a:p>
-          <a:p>
-            <a:r>
-              <a:t>Ingestion note 1 | Recomputed locally from the same saved provider replies acquired under run five-examples-20260926-r1. No new provider requests. Original report 6201ac7a-3540-405f-b234-0346b77f7672 was generated at 2026-09-26T17:38:41+00:00 under method publication-repair-2026-09-24.3; that report is preserved.</a:t>
-            </a:r>
-          </a:p>
-          <a:p>
-            <a:r>
-              <a:t>Ingestion note 2 | Method verdict-consistency-2026-09-26.1: directional model votes require matching explicit verdicts and rating thresholds. Inconclusive replies retain their ratings and remain undecided observations.</a:t>
-            </a:r>
-          </a:p>
-          <a:p>
-            <a:r>
-              <a:t>Ingestion note 3 | Presentation copy of saved report cf784e2f-0554-4bed-8880-c825ae7b8282. The descriptive filename replaces the earlier example ID for navigation. Original analysis dates, provider replies, scores and acquisition context are retained; no new model analysis.</a:t>
+              <a:t>Ingestion note 1 | Fresh provider replies acquired for eleven-examples-refresh-20260926-r1; report assembled locally from the saved responses without further API calls.</a:t>
+            </a:r>
+          </a:p>
+          <a:p>
+            <a:r>
+              <a:t>Ingestion note 2 | Provider latency values are restored from the acquisition receipts (maximum sampled-frame latency per provider); raw replies and assessment results are unchanged by this bookkeeping step.</a:t>
             </a:r>
           </a:p>
         </p:txBody>
@@ -1533,7 +1397,7 @@
           </a:p>
           <a:p>
             <a:r>
-              <a:t>Indicative rating | 5/100</a:t>
+              <a:t>Indicative rating | 4/100</a:t>
             </a:r>
           </a:p>
           <a:p>
@@ -1633,7 +1497,7 @@
           </a:p>
           <a:p>
             <a:r>
-              <a:t>Claude Vision | vision / ok | authentic likely | 5/100</a:t>
+              <a:t>Claude Vision | vision / ok | authentic likely | 4/100</a:t>
             </a:r>
           </a:p>
           <a:p>
@@ -1643,7 +1507,7 @@
           </a:p>
           <a:p>
             <a:r>
-              <a:t>Gemini Vision | vision / ok | authentic likely | 15/100</a:t>
+              <a:t>Gemini Vision | vision / ok | authentic likely | 25/100</a:t>
             </a:r>
           </a:p>
           <a:p>
@@ -1763,47 +1627,42 @@
           </a:p>
           <a:p>
             <a:r>
-              <a:t>Provider summary | synthetic likelihood 5/100; tells: composition matches the widely circulated 1972 Apollo 17 'Blue Marble' photograph (AS17-148-22727), geographically accurate Africa, Arabian Peninsula, Red Sea, Gulf of Aden and Madagascar outlines, Antarctic ice cap consistent with December solstice illumination, physically coherent cloud structures: cyclonic swirls, frontal bands, open-cell cumulus fields</a:t>
-            </a:r>
-          </a:p>
-          <a:p>
-            <a:r>
-              <a:t>Evidence 1 | Composition matches the widely circulated 1972 Apollo 17 'Blue Marble' photograph (AS17-148-22727)</a:t>
-            </a:r>
-          </a:p>
-          <a:p>
-            <a:r>
-              <a:t>Evidence 2 | Geographically accurate Africa, Arabian Peninsula, Red Sea, Gulf of Aden and Madagascar outlines</a:t>
-            </a:r>
-          </a:p>
-          <a:p>
-            <a:r>
-              <a:t>Evidence 3 | Antarctic ice cap consistent with December solstice illumination</a:t>
-            </a:r>
-          </a:p>
-          <a:p>
-            <a:r>
-              <a:t>Evidence 4 | Physically coherent cloud structures: cyclonic swirls, frontal bands, open-cell cumulus fields</a:t>
-            </a:r>
-          </a:p>
-          <a:p>
-            <a:r>
-              <a:t>Evidence 5 | Film-scan grain and slight color cast consistent with analog Hasselblad film digitization</a:t>
-            </a:r>
-          </a:p>
-          <a:p>
-            <a:r>
-              <a:t>Evidence 6 | Natural limb darkening and atmospheric haze at globe edge</a:t>
-            </a:r>
-          </a:p>
-          <a:p>
-            <a:r>
-              <a:t>Evidence 7 | No repeating textures, smeared regions or implausible landmass shapes typical of generative models</a:t>
-            </a:r>
-          </a:p>
-          <a:p>
-            <a:r>
-              <a:t>Evidence 8 | Caveat: Visual match to a famous archival photo is strong, but a high-quality AI recreation or a color-adjusted/re-edited version could look similar; confirm via reverse image search against the NASA archive original and check file metadata.</a:t>
+              <a:t>Provider summary | synthetic likelihood 4/100; tells: visually consistent with the widely documented Apollo 17 'Blue Marble' photograph (NASA AS17-148-22727, Dec 1972), geographically accurate coastlines: Africa, Arabian Peninsula, Red Sea, Gulf of Aden, Madagascar, Antarctic ice cap, physically coherent cloud systems and cyclonic swirls with plausible meteorological structure, film-scan grain and slight color cast consistent with analog photography</a:t>
+            </a:r>
+          </a:p>
+          <a:p>
+            <a:r>
+              <a:t>Evidence 1 | Visually consistent with the widely documented Apollo 17 'Blue Marble' photograph (NASA AS17-148-22727, Dec 1972)</a:t>
+            </a:r>
+          </a:p>
+          <a:p>
+            <a:r>
+              <a:t>Evidence 2 | Geographically accurate coastlines: Africa, Arabian Peninsula, Red Sea, Gulf of Aden, Madagascar, Antarctic ice cap</a:t>
+            </a:r>
+          </a:p>
+          <a:p>
+            <a:r>
+              <a:t>Evidence 3 | Physically coherent cloud systems and cyclonic swirls with plausible meteorological structure</a:t>
+            </a:r>
+          </a:p>
+          <a:p>
+            <a:r>
+              <a:t>Evidence 4 | Film-scan grain and slight color cast consistent with analog photography</a:t>
+            </a:r>
+          </a:p>
+          <a:p>
+            <a:r>
+              <a:t>Evidence 5 | Natural limb shading and terminator-free full-disc illumination consistent with sun behind the camera</a:t>
+            </a:r>
+          </a:p>
+          <a:p>
+            <a:r>
+              <a:t>Evidence 6 | No repeated textures, smeared detail, or generative blending artifacts at land/cloud boundaries</a:t>
+            </a:r>
+          </a:p>
+          <a:p>
+            <a:r>
+              <a:t>Evidence 7 | Caveat: Visual match to a famous archival image is not proof of an unaltered copy; subtle retouching, recoloring, or a high-fidelity regenerated replica cannot be ruled out without comparison to the NASA source scan and metadata/provenance checks.</a:t>
             </a:r>
           </a:p>
         </p:txBody>
@@ -1913,47 +1772,42 @@
           </a:p>
           <a:p>
             <a:r>
-              <a:t>Provider summary | synthetic likelihood 5/100; tells: composition matches the widely circulated 1972 Apollo 17 'Blue Marble' photograph (AS17-148-22727), geographically accurate Africa, Arabian Peninsula, Red Sea, Gulf of Aden and Madagascar outlines, Antarctic ice cap consistent with December solstice illumination, physically coherent cloud structures: cyclonic swirls, frontal bands, open-cell cumulus fields</a:t>
-            </a:r>
-          </a:p>
-          <a:p>
-            <a:r>
-              <a:t>Evidence 1 | Composition matches the widely circulated 1972 Apollo 17 'Blue Marble' photograph (AS17-148-22727)</a:t>
-            </a:r>
-          </a:p>
-          <a:p>
-            <a:r>
-              <a:t>Evidence 2 | Geographically accurate Africa, Arabian Peninsula, Red Sea, Gulf of Aden and Madagascar outlines</a:t>
-            </a:r>
-          </a:p>
-          <a:p>
-            <a:r>
-              <a:t>Evidence 3 | Antarctic ice cap consistent with December solstice illumination</a:t>
-            </a:r>
-          </a:p>
-          <a:p>
-            <a:r>
-              <a:t>Evidence 4 | Physically coherent cloud structures: cyclonic swirls, frontal bands, open-cell cumulus fields</a:t>
-            </a:r>
-          </a:p>
-          <a:p>
-            <a:r>
-              <a:t>Evidence 5 | Film-scan grain and slight color cast consistent with analog Hasselblad film digitization</a:t>
-            </a:r>
-          </a:p>
-          <a:p>
-            <a:r>
-              <a:t>Evidence 6 | Natural limb darkening and atmospheric haze at globe edge</a:t>
-            </a:r>
-          </a:p>
-          <a:p>
-            <a:r>
-              <a:t>Evidence 7 | No repeating textures, smeared regions or implausible landmass shapes typical of generative models</a:t>
-            </a:r>
-          </a:p>
-          <a:p>
-            <a:r>
-              <a:t>Evidence 8 | Caveat: Visual match to a famous archival photo is strong, but a high-quality AI recreation or a color-adjusted/re-edited version could look similar; confirm via reverse image search against the NASA archive original and check file metadata.</a:t>
+              <a:t>Provider summary | synthetic likelihood 4/100; tells: visually consistent with the widely documented Apollo 17 'Blue Marble' photograph (NASA AS17-148-22727, Dec 1972), geographically accurate coastlines: Africa, Arabian Peninsula, Red Sea, Gulf of Aden, Madagascar, Antarctic ice cap, physically coherent cloud systems and cyclonic swirls with plausible meteorological structure, film-scan grain and slight color cast consistent with analog photography</a:t>
+            </a:r>
+          </a:p>
+          <a:p>
+            <a:r>
+              <a:t>Evidence 1 | Visually consistent with the widely documented Apollo 17 'Blue Marble' photograph (NASA AS17-148-22727, Dec 1972)</a:t>
+            </a:r>
+          </a:p>
+          <a:p>
+            <a:r>
+              <a:t>Evidence 2 | Geographically accurate coastlines: Africa, Arabian Peninsula, Red Sea, Gulf of Aden, Madagascar, Antarctic ice cap</a:t>
+            </a:r>
+          </a:p>
+          <a:p>
+            <a:r>
+              <a:t>Evidence 3 | Physically coherent cloud systems and cyclonic swirls with plausible meteorological structure</a:t>
+            </a:r>
+          </a:p>
+          <a:p>
+            <a:r>
+              <a:t>Evidence 4 | Film-scan grain and slight color cast consistent with analog photography</a:t>
+            </a:r>
+          </a:p>
+          <a:p>
+            <a:r>
+              <a:t>Evidence 5 | Natural limb shading and terminator-free full-disc illumination consistent with sun behind the camera</a:t>
+            </a:r>
+          </a:p>
+          <a:p>
+            <a:r>
+              <a:t>Evidence 6 | No repeated textures, smeared detail, or generative blending artifacts at land/cloud boundaries</a:t>
+            </a:r>
+          </a:p>
+          <a:p>
+            <a:r>
+              <a:t>Evidence 7 | Caveat: Visual match to a famous archival image is not proof of an unaltered copy; subtle retouching, recoloring, or a high-fidelity regenerated replica cannot be ruled out without comparison to the NASA source scan and metadata/provenance checks.</a:t>
             </a:r>
           </a:p>
         </p:txBody>
@@ -2063,32 +1917,37 @@
           </a:p>
           <a:p>
             <a:r>
-              <a:t>Provider summary | synthetic likelihood 2/100; tells: Coherent coastlines of Africa, Madagascar and the Arabian Peninsula, Irregular, finely detailed cloud systems with consistent spherical foreshortening, Natural atmospheric haze and gradual shading around Earth's limb, Fine photographic grain and slight color fringing along the globe edge</a:t>
-            </a:r>
-          </a:p>
-          <a:p>
-            <a:r>
-              <a:t>Evidence 1 | Coherent coastlines of Africa, Madagascar and the Arabian Peninsula</a:t>
-            </a:r>
-          </a:p>
-          <a:p>
-            <a:r>
-              <a:t>Evidence 2 | Irregular, finely detailed cloud systems with consistent spherical foreshortening</a:t>
-            </a:r>
-          </a:p>
-          <a:p>
-            <a:r>
-              <a:t>Evidence 3 | Natural atmospheric haze and gradual shading around Earth's limb</a:t>
-            </a:r>
-          </a:p>
-          <a:p>
-            <a:r>
-              <a:t>Evidence 4 | Fine photographic grain and slight color fringing along the globe edge</a:t>
-            </a:r>
-          </a:p>
-          <a:p>
-            <a:r>
-              <a:t>Evidence 5 | Caveat: Resembles the historical Blue Marble photograph; source-file comparison is needed to establish provenance and exclude subtle edits.</a:t>
+              <a:t>Provider summary | synthetic likelihood 2/100; tells: Coherent African, Arabian Peninsula, and Madagascar coastlines, Intricate, nonrepeating cloud bands and storm spirals, Consistent atmospheric haze and foreshortening toward Earth's limb, Fine grain and slight softness consistent with a scanned photograph</a:t>
+            </a:r>
+          </a:p>
+          <a:p>
+            <a:r>
+              <a:t>Evidence 1 | Coherent African, Arabian Peninsula, and Madagascar coastlines</a:t>
+            </a:r>
+          </a:p>
+          <a:p>
+            <a:r>
+              <a:t>Evidence 2 | Intricate, nonrepeating cloud bands and storm spirals</a:t>
+            </a:r>
+          </a:p>
+          <a:p>
+            <a:r>
+              <a:t>Evidence 3 | Consistent atmospheric haze and foreshortening toward Earth's limb</a:t>
+            </a:r>
+          </a:p>
+          <a:p>
+            <a:r>
+              <a:t>Evidence 4 | Fine grain and slight softness consistent with a scanned photograph</a:t>
+            </a:r>
+          </a:p>
+          <a:p>
+            <a:r>
+              <a:t>Evidence 5 | Composition closely resembles the historical Blue Marble photograph</a:t>
+            </a:r>
+          </a:p>
+          <a:p>
+            <a:r>
+              <a:t>Evidence 6 | Caveat: Visual resemblance cannot establish provenance; compare with the archival original to check for subsequent edits.</a:t>
             </a:r>
           </a:p>
         </p:txBody>
@@ -2198,32 +2057,37 @@
           </a:p>
           <a:p>
             <a:r>
-              <a:t>Provider summary | synthetic likelihood 2/100; tells: Coherent coastlines of Africa, Madagascar and the Arabian Peninsula, Irregular, finely detailed cloud systems with consistent spherical foreshortening, Natural atmospheric haze and gradual shading around Earth's limb, Fine photographic grain and slight color fringing along the globe edge</a:t>
-            </a:r>
-          </a:p>
-          <a:p>
-            <a:r>
-              <a:t>Evidence 1 | Coherent coastlines of Africa, Madagascar and the Arabian Peninsula</a:t>
-            </a:r>
-          </a:p>
-          <a:p>
-            <a:r>
-              <a:t>Evidence 2 | Irregular, finely detailed cloud systems with consistent spherical foreshortening</a:t>
-            </a:r>
-          </a:p>
-          <a:p>
-            <a:r>
-              <a:t>Evidence 3 | Natural atmospheric haze and gradual shading around Earth's limb</a:t>
-            </a:r>
-          </a:p>
-          <a:p>
-            <a:r>
-              <a:t>Evidence 4 | Fine photographic grain and slight color fringing along the globe edge</a:t>
-            </a:r>
-          </a:p>
-          <a:p>
-            <a:r>
-              <a:t>Evidence 5 | Caveat: Resembles the historical Blue Marble photograph; source-file comparison is needed to establish provenance and exclude subtle edits.</a:t>
+              <a:t>Provider summary | synthetic likelihood 2/100; tells: Coherent African, Arabian Peninsula, and Madagascar coastlines, Intricate, nonrepeating cloud bands and storm spirals, Consistent atmospheric haze and foreshortening toward Earth's limb, Fine grain and slight softness consistent with a scanned photograph</a:t>
+            </a:r>
+          </a:p>
+          <a:p>
+            <a:r>
+              <a:t>Evidence 1 | Coherent African, Arabian Peninsula, and Madagascar coastlines</a:t>
+            </a:r>
+          </a:p>
+          <a:p>
+            <a:r>
+              <a:t>Evidence 2 | Intricate, nonrepeating cloud bands and storm spirals</a:t>
+            </a:r>
+          </a:p>
+          <a:p>
+            <a:r>
+              <a:t>Evidence 3 | Consistent atmospheric haze and foreshortening toward Earth's limb</a:t>
+            </a:r>
+          </a:p>
+          <a:p>
+            <a:r>
+              <a:t>Evidence 4 | Fine grain and slight softness consistent with a scanned photograph</a:t>
+            </a:r>
+          </a:p>
+          <a:p>
+            <a:r>
+              <a:t>Evidence 5 | Composition closely resembles the historical Blue Marble photograph</a:t>
+            </a:r>
+          </a:p>
+          <a:p>
+            <a:r>
+              <a:t>Evidence 6 | Caveat: Visual resemblance cannot establish provenance; compare with the archival original to check for subsequent edits.</a:t>
             </a:r>
           </a:p>
         </p:txBody>
@@ -2323,7 +2187,7 @@
           </a:p>
           <a:p>
             <a:r>
-              <a:t>Confidence | high</a:t>
+              <a:t>Confidence | medium</a:t>
             </a:r>
           </a:p>
           <a:p>
@@ -2333,32 +2197,32 @@
           </a:p>
           <a:p>
             <a:r>
-              <a:t>Provider summary | synthetic likelihood 15/100; tells: authentic Apollo 17 'Blue Marble' photograph, natural film grain structure, consistent atmospheric limb glow, accurate meteorological cloud swirls</a:t>
-            </a:r>
-          </a:p>
-          <a:p>
-            <a:r>
-              <a:t>Evidence 1 | Authentic Apollo 17 'Blue Marble' photograph</a:t>
-            </a:r>
-          </a:p>
-          <a:p>
-            <a:r>
-              <a:t>Evidence 2 | Natural film grain structure</a:t>
-            </a:r>
-          </a:p>
-          <a:p>
-            <a:r>
-              <a:t>Evidence 3 | Consistent atmospheric limb glow</a:t>
-            </a:r>
-          </a:p>
-          <a:p>
-            <a:r>
-              <a:t>Evidence 4 | Accurate meteorological cloud swirls</a:t>
-            </a:r>
-          </a:p>
-          <a:p>
-            <a:r>
-              <a:t>Evidence 5 | Caveat: High-profile historic images are frequently duplicated, cropped, or color-adjusted across digital archives.</a:t>
+              <a:t>Provider summary | synthetic likelihood 25/100; tells: authentic film grain, consistent atmospheric limb scatter, historically documented cloud formations, natural optical sensor characteristics</a:t>
+            </a:r>
+          </a:p>
+          <a:p>
+            <a:r>
+              <a:t>Evidence 1 | Authentic film grain</a:t>
+            </a:r>
+          </a:p>
+          <a:p>
+            <a:r>
+              <a:t>Evidence 2 | Consistent atmospheric limb scatter</a:t>
+            </a:r>
+          </a:p>
+          <a:p>
+            <a:r>
+              <a:t>Evidence 3 | Historically documented cloud formations</a:t>
+            </a:r>
+          </a:p>
+          <a:p>
+            <a:r>
+              <a:t>Evidence 4 | Natural optical sensor characteristics</a:t>
+            </a:r>
+          </a:p>
+          <a:p>
+            <a:r>
+              <a:t>Evidence 5 | Caveat: High-profile historical images can be digitally remastered or simulated by generative models.</a:t>
             </a:r>
           </a:p>
         </p:txBody>
@@ -2458,7 +2322,7 @@
           </a:p>
           <a:p>
             <a:r>
-              <a:t>Confidence | high</a:t>
+              <a:t>Confidence | medium</a:t>
             </a:r>
           </a:p>
           <a:p>
@@ -2468,32 +2332,32 @@
           </a:p>
           <a:p>
             <a:r>
-              <a:t>Provider summary | synthetic likelihood 15/100; tells: authentic Apollo 17 'Blue Marble' photograph, natural film grain structure, consistent atmospheric limb glow, accurate meteorological cloud swirls</a:t>
-            </a:r>
-          </a:p>
-          <a:p>
-            <a:r>
-              <a:t>Evidence 1 | Authentic Apollo 17 'Blue Marble' photograph</a:t>
-            </a:r>
-          </a:p>
-          <a:p>
-            <a:r>
-              <a:t>Evidence 2 | Natural film grain structure</a:t>
-            </a:r>
-          </a:p>
-          <a:p>
-            <a:r>
-              <a:t>Evidence 3 | Consistent atmospheric limb glow</a:t>
-            </a:r>
-          </a:p>
-          <a:p>
-            <a:r>
-              <a:t>Evidence 4 | Accurate meteorological cloud swirls</a:t>
-            </a:r>
-          </a:p>
-          <a:p>
-            <a:r>
-              <a:t>Evidence 5 | Caveat: High-profile historic images are frequently duplicated, cropped, or color-adjusted across digital archives.</a:t>
+              <a:t>Provider summary | synthetic likelihood 25/100; tells: authentic film grain, consistent atmospheric limb scatter, historically documented cloud formations, natural optical sensor characteristics</a:t>
+            </a:r>
+          </a:p>
+          <a:p>
+            <a:r>
+              <a:t>Evidence 1 | Authentic film grain</a:t>
+            </a:r>
+          </a:p>
+          <a:p>
+            <a:r>
+              <a:t>Evidence 2 | Consistent atmospheric limb scatter</a:t>
+            </a:r>
+          </a:p>
+          <a:p>
+            <a:r>
+              <a:t>Evidence 3 | Historically documented cloud formations</a:t>
+            </a:r>
+          </a:p>
+          <a:p>
+            <a:r>
+              <a:t>Evidence 4 | Natural optical sensor characteristics</a:t>
+            </a:r>
+          </a:p>
+          <a:p>
+            <a:r>
+              <a:t>Evidence 5 | Caveat: High-profile historical images can be digitally remastered or simulated by generative models.</a:t>
             </a:r>
           </a:p>
         </p:txBody>
@@ -8851,7 +8715,7 @@
         </p:nvGraphicFramePr>
         <p:xfrm>
           <a:off x="365760" y="1700784"/>
-          <a:ext cx="8412479" cy="1162304"/>
+          <a:ext cx="8412479" cy="1365503"/>
         </p:xfrm>
         <a:graphic>
           <a:graphicData uri="http://schemas.openxmlformats.org/drawingml/2006/table">
@@ -8863,7 +8727,7 @@
                 <a:gridCol w="2271369"/>
                 <a:gridCol w="6141110"/>
               </a:tblGrid>
-              <a:tr h="1162304">
+              <a:tr h="1365503">
                 <a:tc>
                   <a:txBody>
                     <a:bodyPr wrap="none"/>
@@ -8914,83 +8778,102 @@
                         </a:defRPr>
                       </a:pPr>
                       <a:r>
-                        <a:t>synthetic likelihood 5/100; tells: composition matches the widely circulated 1972</a:t>
-                      </a:r>
-                    </a:p>
-                    <a:p>
-                      <a:pPr>
-                        <a:lnSpc>
-                          <a:spcPts val="1600"/>
-                        </a:lnSpc>
-                        <a:spcAft>
-                          <a:spcPts val="0"/>
-                        </a:spcAft>
-                        <a:defRPr sz="1200" b="0">
-                          <a:solidFill>
-                            <a:srgbClr val="21243A"/>
-                          </a:solidFill>
-                          <a:latin typeface="Arial"/>
-                        </a:defRPr>
-                      </a:pPr>
-                      <a:r>
-                        <a:t>Apollo 17 'Blue Marble' photograph (AS17-148-22727), geographically accurate</a:t>
-                      </a:r>
-                    </a:p>
-                    <a:p>
-                      <a:pPr>
-                        <a:lnSpc>
-                          <a:spcPts val="1600"/>
-                        </a:lnSpc>
-                        <a:spcAft>
-                          <a:spcPts val="0"/>
-                        </a:spcAft>
-                        <a:defRPr sz="1200" b="0">
-                          <a:solidFill>
-                            <a:srgbClr val="21243A"/>
-                          </a:solidFill>
-                          <a:latin typeface="Arial"/>
-                        </a:defRPr>
-                      </a:pPr>
-                      <a:r>
-                        <a:t>Africa, Arabian Peninsula, Red Sea, Gulf of Aden and Madagascar outlines,</a:t>
-                      </a:r>
-                    </a:p>
-                    <a:p>
-                      <a:pPr>
-                        <a:lnSpc>
-                          <a:spcPts val="1600"/>
-                        </a:lnSpc>
-                        <a:spcAft>
-                          <a:spcPts val="0"/>
-                        </a:spcAft>
-                        <a:defRPr sz="1200" b="0">
-                          <a:solidFill>
-                            <a:srgbClr val="21243A"/>
-                          </a:solidFill>
-                          <a:latin typeface="Arial"/>
-                        </a:defRPr>
-                      </a:pPr>
-                      <a:r>
-                        <a:t>Antarctic ice cap consistent with December solstice illumination, physically</a:t>
-                      </a:r>
-                    </a:p>
-                    <a:p>
-                      <a:pPr>
-                        <a:lnSpc>
-                          <a:spcPts val="1600"/>
-                        </a:lnSpc>
-                        <a:spcAft>
-                          <a:spcPts val="0"/>
-                        </a:spcAft>
-                        <a:defRPr sz="1200" b="0">
-                          <a:solidFill>
-                            <a:srgbClr val="21243A"/>
-                          </a:solidFill>
-                          <a:latin typeface="Arial"/>
-                        </a:defRPr>
-                      </a:pPr>
-                      <a:r>
-                        <a:t>coherent cloud structures: cyclonic swirls, frontal bands, open-cell cumulus fields</a:t>
+                        <a:t>synthetic likelihood 4/100; tells: visually consistent with the widely documented</a:t>
+                      </a:r>
+                    </a:p>
+                    <a:p>
+                      <a:pPr>
+                        <a:lnSpc>
+                          <a:spcPts val="1600"/>
+                        </a:lnSpc>
+                        <a:spcAft>
+                          <a:spcPts val="0"/>
+                        </a:spcAft>
+                        <a:defRPr sz="1200" b="0">
+                          <a:solidFill>
+                            <a:srgbClr val="21243A"/>
+                          </a:solidFill>
+                          <a:latin typeface="Arial"/>
+                        </a:defRPr>
+                      </a:pPr>
+                      <a:r>
+                        <a:t>Apollo 17 'Blue Marble' photograph (NASA AS17-148-22727, Dec 1972),</a:t>
+                      </a:r>
+                    </a:p>
+                    <a:p>
+                      <a:pPr>
+                        <a:lnSpc>
+                          <a:spcPts val="1600"/>
+                        </a:lnSpc>
+                        <a:spcAft>
+                          <a:spcPts val="0"/>
+                        </a:spcAft>
+                        <a:defRPr sz="1200" b="0">
+                          <a:solidFill>
+                            <a:srgbClr val="21243A"/>
+                          </a:solidFill>
+                          <a:latin typeface="Arial"/>
+                        </a:defRPr>
+                      </a:pPr>
+                      <a:r>
+                        <a:t>geographically accurate coastlines: Africa, Arabian Peninsula, Red Sea, Gulf of</a:t>
+                      </a:r>
+                    </a:p>
+                    <a:p>
+                      <a:pPr>
+                        <a:lnSpc>
+                          <a:spcPts val="1600"/>
+                        </a:lnSpc>
+                        <a:spcAft>
+                          <a:spcPts val="0"/>
+                        </a:spcAft>
+                        <a:defRPr sz="1200" b="0">
+                          <a:solidFill>
+                            <a:srgbClr val="21243A"/>
+                          </a:solidFill>
+                          <a:latin typeface="Arial"/>
+                        </a:defRPr>
+                      </a:pPr>
+                      <a:r>
+                        <a:t>Aden, Madagascar, Antarctic ice cap, physically coherent cloud systems and</a:t>
+                      </a:r>
+                    </a:p>
+                    <a:p>
+                      <a:pPr>
+                        <a:lnSpc>
+                          <a:spcPts val="1600"/>
+                        </a:lnSpc>
+                        <a:spcAft>
+                          <a:spcPts val="0"/>
+                        </a:spcAft>
+                        <a:defRPr sz="1200" b="0">
+                          <a:solidFill>
+                            <a:srgbClr val="21243A"/>
+                          </a:solidFill>
+                          <a:latin typeface="Arial"/>
+                        </a:defRPr>
+                      </a:pPr>
+                      <a:r>
+                        <a:t>cyclonic swirls with plausible meteorological structure, film-scan grain and slight</a:t>
+                      </a:r>
+                    </a:p>
+                    <a:p>
+                      <a:pPr>
+                        <a:lnSpc>
+                          <a:spcPts val="1600"/>
+                        </a:lnSpc>
+                        <a:spcAft>
+                          <a:spcPts val="0"/>
+                        </a:spcAft>
+                        <a:defRPr sz="1200" b="0">
+                          <a:solidFill>
+                            <a:srgbClr val="21243A"/>
+                          </a:solidFill>
+                          <a:latin typeface="Arial"/>
+                        </a:defRPr>
+                      </a:pPr>
+                      <a:r>
+                        <a:t>color cast consistent with analog photography</a:t>
                       </a:r>
                     </a:p>
                   </a:txBody>
@@ -9014,8 +8897,8 @@
           <p:nvPr/>
         </p:nvGraphicFramePr>
         <p:xfrm>
-          <a:off x="365760" y="2863088"/>
-          <a:ext cx="8412479" cy="1162304"/>
+          <a:off x="365760" y="3066288"/>
+          <a:ext cx="8412479" cy="959103"/>
         </p:xfrm>
         <a:graphic>
           <a:graphicData uri="http://schemas.openxmlformats.org/drawingml/2006/table">
@@ -9027,7 +8910,7 @@
                 <a:gridCol w="2271369"/>
                 <a:gridCol w="6141110"/>
               </a:tblGrid>
-              <a:tr h="1162304">
+              <a:tr h="959103">
                 <a:tc>
                   <a:txBody>
                     <a:bodyPr wrap="none"/>
@@ -9078,83 +8961,64 @@
                         </a:defRPr>
                       </a:pPr>
                       <a:r>
-                        <a:t>synthetic likelihood 2/100; tells: Coherent coastlines of Africa, Madagascar and the</a:t>
-                      </a:r>
-                    </a:p>
-                    <a:p>
-                      <a:pPr>
-                        <a:lnSpc>
-                          <a:spcPts val="1600"/>
-                        </a:lnSpc>
-                        <a:spcAft>
-                          <a:spcPts val="0"/>
-                        </a:spcAft>
-                        <a:defRPr sz="1200" b="0">
-                          <a:solidFill>
-                            <a:srgbClr val="21243A"/>
-                          </a:solidFill>
-                          <a:latin typeface="Arial"/>
-                        </a:defRPr>
-                      </a:pPr>
-                      <a:r>
-                        <a:t>Arabian Peninsula, Irregular, finely detailed cloud systems with consistent</a:t>
-                      </a:r>
-                    </a:p>
-                    <a:p>
-                      <a:pPr>
-                        <a:lnSpc>
-                          <a:spcPts val="1600"/>
-                        </a:lnSpc>
-                        <a:spcAft>
-                          <a:spcPts val="0"/>
-                        </a:spcAft>
-                        <a:defRPr sz="1200" b="0">
-                          <a:solidFill>
-                            <a:srgbClr val="21243A"/>
-                          </a:solidFill>
-                          <a:latin typeface="Arial"/>
-                        </a:defRPr>
-                      </a:pPr>
-                      <a:r>
-                        <a:t>spherical foreshortening, Natural atmospheric haze and gradual shading around</a:t>
-                      </a:r>
-                    </a:p>
-                    <a:p>
-                      <a:pPr>
-                        <a:lnSpc>
-                          <a:spcPts val="1600"/>
-                        </a:lnSpc>
-                        <a:spcAft>
-                          <a:spcPts val="0"/>
-                        </a:spcAft>
-                        <a:defRPr sz="1200" b="0">
-                          <a:solidFill>
-                            <a:srgbClr val="21243A"/>
-                          </a:solidFill>
-                          <a:latin typeface="Arial"/>
-                        </a:defRPr>
-                      </a:pPr>
-                      <a:r>
-                        <a:t>Earth's limb, Fine photographic grain and slight color fringing along the globe</a:t>
-                      </a:r>
-                    </a:p>
-                    <a:p>
-                      <a:pPr>
-                        <a:lnSpc>
-                          <a:spcPts val="1600"/>
-                        </a:lnSpc>
-                        <a:spcAft>
-                          <a:spcPts val="0"/>
-                        </a:spcAft>
-                        <a:defRPr sz="1200" b="0">
-                          <a:solidFill>
-                            <a:srgbClr val="21243A"/>
-                          </a:solidFill>
-                          <a:latin typeface="Arial"/>
-                        </a:defRPr>
-                      </a:pPr>
-                      <a:r>
-                        <a:t>edge</a:t>
+                        <a:t>synthetic likelihood 2/100; tells: Coherent African, Arabian Peninsula, and</a:t>
+                      </a:r>
+                    </a:p>
+                    <a:p>
+                      <a:pPr>
+                        <a:lnSpc>
+                          <a:spcPts val="1600"/>
+                        </a:lnSpc>
+                        <a:spcAft>
+                          <a:spcPts val="0"/>
+                        </a:spcAft>
+                        <a:defRPr sz="1200" b="0">
+                          <a:solidFill>
+                            <a:srgbClr val="21243A"/>
+                          </a:solidFill>
+                          <a:latin typeface="Arial"/>
+                        </a:defRPr>
+                      </a:pPr>
+                      <a:r>
+                        <a:t>Madagascar coastlines, Intricate, nonrepeating cloud bands and storm spirals,</a:t>
+                      </a:r>
+                    </a:p>
+                    <a:p>
+                      <a:pPr>
+                        <a:lnSpc>
+                          <a:spcPts val="1600"/>
+                        </a:lnSpc>
+                        <a:spcAft>
+                          <a:spcPts val="0"/>
+                        </a:spcAft>
+                        <a:defRPr sz="1200" b="0">
+                          <a:solidFill>
+                            <a:srgbClr val="21243A"/>
+                          </a:solidFill>
+                          <a:latin typeface="Arial"/>
+                        </a:defRPr>
+                      </a:pPr>
+                      <a:r>
+                        <a:t>Consistent atmospheric haze and foreshortening toward Earth's limb, Fine grain</a:t>
+                      </a:r>
+                    </a:p>
+                    <a:p>
+                      <a:pPr>
+                        <a:lnSpc>
+                          <a:spcPts val="1600"/>
+                        </a:lnSpc>
+                        <a:spcAft>
+                          <a:spcPts val="0"/>
+                        </a:spcAft>
+                        <a:defRPr sz="1200" b="0">
+                          <a:solidFill>
+                            <a:srgbClr val="21243A"/>
+                          </a:solidFill>
+                          <a:latin typeface="Arial"/>
+                        </a:defRPr>
+                      </a:pPr>
+                      <a:r>
+                        <a:t>and slight softness consistent with a scanned photograph</a:t>
                       </a:r>
                     </a:p>
                   </a:txBody>
@@ -9242,45 +9106,45 @@
                         </a:defRPr>
                       </a:pPr>
                       <a:r>
-                        <a:t>synthetic likelihood 15/100; tells: authentic Apollo 17 'Blue Marble' photograph,</a:t>
-                      </a:r>
-                    </a:p>
-                    <a:p>
-                      <a:pPr>
-                        <a:lnSpc>
-                          <a:spcPts val="1600"/>
-                        </a:lnSpc>
-                        <a:spcAft>
-                          <a:spcPts val="0"/>
-                        </a:spcAft>
-                        <a:defRPr sz="1200" b="0">
-                          <a:solidFill>
-                            <a:srgbClr val="21243A"/>
-                          </a:solidFill>
-                          <a:latin typeface="Arial"/>
-                        </a:defRPr>
-                      </a:pPr>
-                      <a:r>
-                        <a:t>natural film grain structure, consistent atmospheric limb glow, accurate</a:t>
-                      </a:r>
-                    </a:p>
-                    <a:p>
-                      <a:pPr>
-                        <a:lnSpc>
-                          <a:spcPts val="1600"/>
-                        </a:lnSpc>
-                        <a:spcAft>
-                          <a:spcPts val="0"/>
-                        </a:spcAft>
-                        <a:defRPr sz="1200" b="0">
-                          <a:solidFill>
-                            <a:srgbClr val="21243A"/>
-                          </a:solidFill>
-                          <a:latin typeface="Arial"/>
-                        </a:defRPr>
-                      </a:pPr>
-                      <a:r>
-                        <a:t>meteorological cloud swirls</a:t>
+                        <a:t>synthetic likelihood 25/100; tells: authentic film grain, consistent atmospheric limb</a:t>
+                      </a:r>
+                    </a:p>
+                    <a:p>
+                      <a:pPr>
+                        <a:lnSpc>
+                          <a:spcPts val="1600"/>
+                        </a:lnSpc>
+                        <a:spcAft>
+                          <a:spcPts val="0"/>
+                        </a:spcAft>
+                        <a:defRPr sz="1200" b="0">
+                          <a:solidFill>
+                            <a:srgbClr val="21243A"/>
+                          </a:solidFill>
+                          <a:latin typeface="Arial"/>
+                        </a:defRPr>
+                      </a:pPr>
+                      <a:r>
+                        <a:t>scatter, historically documented cloud formations, natural optical sensor</a:t>
+                      </a:r>
+                    </a:p>
+                    <a:p>
+                      <a:pPr>
+                        <a:lnSpc>
+                          <a:spcPts val="1600"/>
+                        </a:lnSpc>
+                        <a:spcAft>
+                          <a:spcPts val="0"/>
+                        </a:spcAft>
+                        <a:defRPr sz="1200" b="0">
+                          <a:solidFill>
+                            <a:srgbClr val="21243A"/>
+                          </a:solidFill>
+                          <a:latin typeface="Arial"/>
+                        </a:defRPr>
+                      </a:pPr>
+                      <a:r>
+                        <a:t>characteristics</a:t>
                       </a:r>
                     </a:p>
                   </a:txBody>
@@ -10794,7 +10658,7 @@
                         </a:defRPr>
                       </a:pPr>
                       <a:r>
-                        <a:t>b8bb2ceb-20cc-4afd-a616-7cbaace7f08a</a:t>
+                        <a:t>afa06964-dc8c-4c81-8fc7-b6179d9b2705</a:t>
                       </a:r>
                     </a:p>
                   </a:txBody>
@@ -10882,7 +10746,7 @@
                         </a:defRPr>
                       </a:pPr>
                       <a:r>
-                        <a:t>2026-09-26T17:54:47+00:00</a:t>
+                        <a:t>2026-09-26T22:31:03+00:00</a:t>
                       </a:r>
                     </a:p>
                   </a:txBody>
@@ -11146,7 +11010,7 @@
                         </a:defRPr>
                       </a:pPr>
                       <a:r>
-                        <a:t>verdict-consistency-2026-09-26.1</a:t>
+                        <a:t>pdf-preparation-2026-09-26.1</a:t>
                       </a:r>
                     </a:p>
                   </a:txBody>
@@ -11347,7 +11211,7 @@
         </p:nvGraphicFramePr>
         <p:xfrm>
           <a:off x="365760" y="4496816"/>
-          <a:ext cx="8412479" cy="1162304"/>
+          <a:ext cx="8412479" cy="552704"/>
         </p:xfrm>
         <a:graphic>
           <a:graphicData uri="http://schemas.openxmlformats.org/drawingml/2006/table">
@@ -11359,7 +11223,7 @@
                 <a:gridCol w="2271369"/>
                 <a:gridCol w="6141110"/>
               </a:tblGrid>
-              <a:tr h="1162304">
+              <a:tr h="552704">
                 <a:tc>
                   <a:txBody>
                     <a:bodyPr wrap="none"/>
@@ -11410,363 +11274,32 @@
                         </a:defRPr>
                       </a:pPr>
                       <a:r>
-                        <a:t>Recomputed locally from the same saved provider replies acquired under run</a:t>
-                      </a:r>
-                    </a:p>
-                    <a:p>
-                      <a:pPr>
-                        <a:lnSpc>
-                          <a:spcPts val="1600"/>
-                        </a:lnSpc>
-                        <a:spcAft>
-                          <a:spcPts val="0"/>
-                        </a:spcAft>
-                        <a:defRPr sz="1200" b="0">
-                          <a:solidFill>
-                            <a:srgbClr val="21243A"/>
-                          </a:solidFill>
-                          <a:latin typeface="Arial"/>
-                        </a:defRPr>
-                      </a:pPr>
-                      <a:r>
-                        <a:t>five-examples-20260926-r1. No new provider requests. Original report</a:t>
-                      </a:r>
-                    </a:p>
-                    <a:p>
-                      <a:pPr>
-                        <a:lnSpc>
-                          <a:spcPts val="1600"/>
-                        </a:lnSpc>
-                        <a:spcAft>
-                          <a:spcPts val="0"/>
-                        </a:spcAft>
-                        <a:defRPr sz="1200" b="0">
-                          <a:solidFill>
-                            <a:srgbClr val="21243A"/>
-                          </a:solidFill>
-                          <a:latin typeface="Arial"/>
-                        </a:defRPr>
-                      </a:pPr>
-                      <a:r>
-                        <a:t>6201ac7a-3540-405f-b234-0346b77f7672 was generated at</a:t>
-                      </a:r>
-                    </a:p>
-                    <a:p>
-                      <a:pPr>
-                        <a:lnSpc>
-                          <a:spcPts val="1600"/>
-                        </a:lnSpc>
-                        <a:spcAft>
-                          <a:spcPts val="0"/>
-                        </a:spcAft>
-                        <a:defRPr sz="1200" b="0">
-                          <a:solidFill>
-                            <a:srgbClr val="21243A"/>
-                          </a:solidFill>
-                          <a:latin typeface="Arial"/>
-                        </a:defRPr>
-                      </a:pPr>
-                      <a:r>
-                        <a:t>2026-09-26T17:38:41+00:00 under method publication-repair-2026-09-24.3; that</a:t>
-                      </a:r>
-                    </a:p>
-                    <a:p>
-                      <a:pPr>
-                        <a:lnSpc>
-                          <a:spcPts val="1600"/>
-                        </a:lnSpc>
-                        <a:spcAft>
-                          <a:spcPts val="0"/>
-                        </a:spcAft>
-                        <a:defRPr sz="1200" b="0">
-                          <a:solidFill>
-                            <a:srgbClr val="21243A"/>
-                          </a:solidFill>
-                          <a:latin typeface="Arial"/>
-                        </a:defRPr>
-                      </a:pPr>
-                      <a:r>
-                        <a:t>report is preserved.</a:t>
+                        <a:t>Fresh provider replies acquired for eleven-examples-refresh-20260926-r1; report</a:t>
+                      </a:r>
+                    </a:p>
+                    <a:p>
+                      <a:pPr>
+                        <a:lnSpc>
+                          <a:spcPts val="1600"/>
+                        </a:lnSpc>
+                        <a:spcAft>
+                          <a:spcPts val="0"/>
+                        </a:spcAft>
+                        <a:defRPr sz="1200" b="0">
+                          <a:solidFill>
+                            <a:srgbClr val="21243A"/>
+                          </a:solidFill>
+                          <a:latin typeface="Arial"/>
+                        </a:defRPr>
+                      </a:pPr>
+                      <a:r>
+                        <a:t>assembled locally from the saved responses without further API calls.</a:t>
                       </a:r>
                     </a:p>
                   </a:txBody>
                   <a:tcPr marL="82296" marR="82296" marT="64008" marB="64008">
                     <a:solidFill>
                       <a:srgbClr val="F1F7F7"/>
-                    </a:solidFill>
-                  </a:tcPr>
-                </a:tc>
-              </a:tr>
-            </a:tbl>
-          </a:graphicData>
-        </a:graphic>
-      </p:graphicFrame>
-    </p:spTree>
-  </p:cSld>
-  <p:clrMapOvr>
-    <a:masterClrMapping/>
-  </p:clrMapOvr>
-</p:sld>
-</file>
-
-<file path=ppt/slides/slide17.xml><?xml version="1.0" encoding="utf-8"?>
-<p:sld xmlns:a="http://schemas.openxmlformats.org/drawingml/2006/main" xmlns:p="http://schemas.openxmlformats.org/presentationml/2006/main" xmlns:r="http://schemas.openxmlformats.org/officeDocument/2006/relationships">
-  <p:cSld>
-    <p:spTree>
-      <p:nvGrpSpPr>
-        <p:cNvPr id="1" name=""/>
-        <p:cNvGrpSpPr/>
-        <p:nvPr/>
-      </p:nvGrpSpPr>
-      <p:grpSpPr/>
-      <p:sp>
-        <p:nvSpPr>
-          <p:cNvPr id="2" name="TextBox 1"/>
-          <p:cNvSpPr txBox="1"/>
-          <p:nvPr/>
-        </p:nvSpPr>
-        <p:spPr>
-          <a:xfrm>
-            <a:off x="365760" y="219456"/>
-            <a:ext cx="8412480" cy="228600"/>
-          </a:xfrm>
-          <a:prstGeom prst="rect">
-            <a:avLst/>
-          </a:prstGeom>
-          <a:noFill/>
-        </p:spPr>
-        <p:txBody>
-          <a:bodyPr wrap="square" lIns="0" rIns="0" tIns="0" bIns="0">
-            <a:spAutoFit/>
-          </a:bodyPr>
-          <a:lstStyle/>
-          <a:p>
-            <a:pPr>
-              <a:lnSpc>
-                <a:spcPct val="115000"/>
-              </a:lnSpc>
-              <a:spcAft>
-                <a:spcPts val="0"/>
-              </a:spcAft>
-              <a:defRPr sz="1100" b="1">
-                <a:solidFill>
-                  <a:srgbClr val="C5006A"/>
-                </a:solidFill>
-                <a:latin typeface="Arial"/>
-              </a:defRPr>
-            </a:pPr>
-            <a:r>
-              <a:t>SDA VISION / RESEARCH REPORT</a:t>
-            </a:r>
-          </a:p>
-        </p:txBody>
-      </p:sp>
-      <p:sp>
-        <p:nvSpPr>
-          <p:cNvPr id="3" name="TextBox 2"/>
-          <p:cNvSpPr txBox="1"/>
-          <p:nvPr/>
-        </p:nvSpPr>
-        <p:spPr>
-          <a:xfrm>
-            <a:off x="365760" y="658368"/>
-            <a:ext cx="8412480" cy="612648"/>
-          </a:xfrm>
-          <a:prstGeom prst="rect">
-            <a:avLst/>
-          </a:prstGeom>
-          <a:noFill/>
-        </p:spPr>
-        <p:txBody>
-          <a:bodyPr wrap="square" lIns="0" rIns="0" tIns="0" bIns="0">
-            <a:spAutoFit/>
-          </a:bodyPr>
-          <a:lstStyle/>
-          <a:p>
-            <a:pPr>
-              <a:lnSpc>
-                <a:spcPct val="115000"/>
-              </a:lnSpc>
-              <a:spcAft>
-                <a:spcPts val="0"/>
-              </a:spcAft>
-              <a:defRPr sz="2200" b="1">
-                <a:solidFill>
-                  <a:srgbClr val="21243A"/>
-                </a:solidFill>
-                <a:latin typeface="Arial"/>
-              </a:defRPr>
-            </a:pPr>
-            <a:r>
-              <a:t>File and analysis record (continued)</a:t>
-            </a:r>
-          </a:p>
-        </p:txBody>
-      </p:sp>
-      <p:sp>
-        <p:nvSpPr>
-          <p:cNvPr id="4" name="TextBox 3"/>
-          <p:cNvSpPr txBox="1"/>
-          <p:nvPr/>
-        </p:nvSpPr>
-        <p:spPr>
-          <a:xfrm>
-            <a:off x="365760" y="6291072"/>
-            <a:ext cx="8001000" cy="365760"/>
-          </a:xfrm>
-          <a:prstGeom prst="rect">
-            <a:avLst/>
-          </a:prstGeom>
-          <a:noFill/>
-        </p:spPr>
-        <p:txBody>
-          <a:bodyPr wrap="square" lIns="0" rIns="0" tIns="0" bIns="0">
-            <a:spAutoFit/>
-          </a:bodyPr>
-          <a:lstStyle/>
-          <a:p>
-            <a:pPr>
-              <a:lnSpc>
-                <a:spcPct val="115000"/>
-              </a:lnSpc>
-              <a:spcAft>
-                <a:spcPts val="0"/>
-              </a:spcAft>
-              <a:defRPr sz="800" b="0">
-                <a:solidFill>
-                  <a:srgbClr val="545B6D"/>
-                </a:solidFill>
-                <a:latin typeface="Arial"/>
-              </a:defRPr>
-            </a:pPr>
-            <a:r>
-              <a:t>Research assessment. Ratings are not calibrated probabilities.</a:t>
-            </a:r>
-          </a:p>
-        </p:txBody>
-      </p:sp>
-      <p:sp>
-        <p:nvSpPr>
-          <p:cNvPr id="5" name="TextBox 4"/>
-          <p:cNvSpPr txBox="1"/>
-          <p:nvPr/>
-        </p:nvSpPr>
-        <p:spPr>
-          <a:xfrm>
-            <a:off x="8394192" y="6318504"/>
-            <a:ext cx="365760" cy="228600"/>
-          </a:xfrm>
-          <a:prstGeom prst="rect">
-            <a:avLst/>
-          </a:prstGeom>
-          <a:noFill/>
-        </p:spPr>
-        <p:txBody>
-          <a:bodyPr wrap="square" lIns="0" rIns="0" tIns="0" bIns="0">
-            <a:spAutoFit/>
-          </a:bodyPr>
-          <a:lstStyle/>
-          <a:p>
-            <a:pPr>
-              <a:lnSpc>
-                <a:spcPct val="115000"/>
-              </a:lnSpc>
-              <a:spcAft>
-                <a:spcPts val="0"/>
-              </a:spcAft>
-              <a:defRPr sz="900" b="0">
-                <a:solidFill>
-                  <a:srgbClr val="545B6D"/>
-                </a:solidFill>
-                <a:latin typeface="Arial"/>
-              </a:defRPr>
-            </a:pPr>
-            <a:r>
-              <a:t>17</a:t>
-            </a:r>
-          </a:p>
-        </p:txBody>
-      </p:sp>
-      <p:graphicFrame>
-        <p:nvGraphicFramePr>
-          <p:cNvPr id="6" name="Table 5"/>
-          <p:cNvGraphicFramePr>
-            <a:graphicFrameLocks noGrp="1"/>
-          </p:cNvGraphicFramePr>
-          <p:nvPr/>
-        </p:nvGraphicFramePr>
-        <p:xfrm>
-          <a:off x="365760" y="1353312"/>
-          <a:ext cx="8412479" cy="347472"/>
-        </p:xfrm>
-        <a:graphic>
-          <a:graphicData uri="http://schemas.openxmlformats.org/drawingml/2006/table">
-            <a:tbl>
-              <a:tblPr firstRow="1" bandRow="1">
-                <a:tableStyleId>{5C22544A-7EE6-4342-B048-85BDC9FD1C3A}</a:tableStyleId>
-              </a:tblPr>
-              <a:tblGrid>
-                <a:gridCol w="2271369"/>
-                <a:gridCol w="6141110"/>
-              </a:tblGrid>
-              <a:tr h="347472">
-                <a:tc>
-                  <a:txBody>
-                    <a:bodyPr wrap="none"/>
-                    <a:lstStyle/>
-                    <a:p>
-                      <a:pPr>
-                        <a:lnSpc>
-                          <a:spcPts val="1600"/>
-                        </a:lnSpc>
-                        <a:spcAft>
-                          <a:spcPts val="0"/>
-                        </a:spcAft>
-                        <a:defRPr sz="1200" b="1">
-                          <a:solidFill>
-                            <a:srgbClr val="FFFFFF"/>
-                          </a:solidFill>
-                          <a:latin typeface="Arial"/>
-                        </a:defRPr>
-                      </a:pPr>
-                      <a:r>
-                        <a:t>Field</a:t>
-                      </a:r>
-                    </a:p>
-                  </a:txBody>
-                  <a:tcPr marL="82296" marR="82296" marT="64008" marB="64008">
-                    <a:solidFill>
-                      <a:srgbClr val="16787C"/>
-                    </a:solidFill>
-                  </a:tcPr>
-                </a:tc>
-                <a:tc>
-                  <a:txBody>
-                    <a:bodyPr wrap="none"/>
-                    <a:lstStyle/>
-                    <a:p>
-                      <a:pPr>
-                        <a:lnSpc>
-                          <a:spcPts val="1600"/>
-                        </a:lnSpc>
-                        <a:spcAft>
-                          <a:spcPts val="0"/>
-                        </a:spcAft>
-                        <a:defRPr sz="1200" b="1">
-                          <a:solidFill>
-                            <a:srgbClr val="FFFFFF"/>
-                          </a:solidFill>
-                          <a:latin typeface="Arial"/>
-                        </a:defRPr>
-                      </a:pPr>
-                      <a:r>
-                        <a:t>Recorded detail</a:t>
-                      </a:r>
-                    </a:p>
-                  </a:txBody>
-                  <a:tcPr marL="82296" marR="82296" marT="64008" marB="64008">
-                    <a:solidFill>
-                      <a:srgbClr val="16787C"/>
                     </a:solidFill>
                   </a:tcPr>
                 </a:tc>
@@ -11777,14 +11310,14 @@
       </p:graphicFrame>
       <p:graphicFrame>
         <p:nvGraphicFramePr>
-          <p:cNvPr id="7" name="Table 6"/>
+          <p:cNvPr id="16" name="Table 15"/>
           <p:cNvGraphicFramePr>
             <a:graphicFrameLocks noGrp="1"/>
           </p:cNvGraphicFramePr>
           <p:nvPr/>
         </p:nvGraphicFramePr>
         <p:xfrm>
-          <a:off x="365760" y="1700784"/>
+          <a:off x="365760" y="5049520"/>
           <a:ext cx="8412479" cy="755904"/>
         </p:xfrm>
         <a:graphic>
@@ -11848,196 +11381,51 @@
                         </a:defRPr>
                       </a:pPr>
                       <a:r>
-                        <a:t>Method verdict-consistency-2026-09-26.1: directional model votes require</a:t>
-                      </a:r>
-                    </a:p>
-                    <a:p>
-                      <a:pPr>
-                        <a:lnSpc>
-                          <a:spcPts val="1600"/>
-                        </a:lnSpc>
-                        <a:spcAft>
-                          <a:spcPts val="0"/>
-                        </a:spcAft>
-                        <a:defRPr sz="1200" b="0">
-                          <a:solidFill>
-                            <a:srgbClr val="21243A"/>
-                          </a:solidFill>
-                          <a:latin typeface="Arial"/>
-                        </a:defRPr>
-                      </a:pPr>
-                      <a:r>
-                        <a:t>matching explicit verdicts and rating thresholds. Inconclusive replies retain their</a:t>
-                      </a:r>
-                    </a:p>
-                    <a:p>
-                      <a:pPr>
-                        <a:lnSpc>
-                          <a:spcPts val="1600"/>
-                        </a:lnSpc>
-                        <a:spcAft>
-                          <a:spcPts val="0"/>
-                        </a:spcAft>
-                        <a:defRPr sz="1200" b="0">
-                          <a:solidFill>
-                            <a:srgbClr val="21243A"/>
-                          </a:solidFill>
-                          <a:latin typeface="Arial"/>
-                        </a:defRPr>
-                      </a:pPr>
-                      <a:r>
-                        <a:t>ratings and remain undecided observations.</a:t>
+                        <a:t>Provider latency values are restored from the acquisition receipts (maximum</a:t>
+                      </a:r>
+                    </a:p>
+                    <a:p>
+                      <a:pPr>
+                        <a:lnSpc>
+                          <a:spcPts val="1600"/>
+                        </a:lnSpc>
+                        <a:spcAft>
+                          <a:spcPts val="0"/>
+                        </a:spcAft>
+                        <a:defRPr sz="1200" b="0">
+                          <a:solidFill>
+                            <a:srgbClr val="21243A"/>
+                          </a:solidFill>
+                          <a:latin typeface="Arial"/>
+                        </a:defRPr>
+                      </a:pPr>
+                      <a:r>
+                        <a:t>sampled-frame latency per provider); raw replies and assessment results are</a:t>
+                      </a:r>
+                    </a:p>
+                    <a:p>
+                      <a:pPr>
+                        <a:lnSpc>
+                          <a:spcPts val="1600"/>
+                        </a:lnSpc>
+                        <a:spcAft>
+                          <a:spcPts val="0"/>
+                        </a:spcAft>
+                        <a:defRPr sz="1200" b="0">
+                          <a:solidFill>
+                            <a:srgbClr val="21243A"/>
+                          </a:solidFill>
+                          <a:latin typeface="Arial"/>
+                        </a:defRPr>
+                      </a:pPr>
+                      <a:r>
+                        <a:t>unchanged by this bookkeeping step.</a:t>
                       </a:r>
                     </a:p>
                   </a:txBody>
                   <a:tcPr marL="82296" marR="82296" marT="64008" marB="64008">
                     <a:solidFill>
                       <a:srgbClr val="FFFFFF"/>
-                    </a:solidFill>
-                  </a:tcPr>
-                </a:tc>
-              </a:tr>
-            </a:tbl>
-          </a:graphicData>
-        </a:graphic>
-      </p:graphicFrame>
-      <p:graphicFrame>
-        <p:nvGraphicFramePr>
-          <p:cNvPr id="8" name="Table 7"/>
-          <p:cNvGraphicFramePr>
-            <a:graphicFrameLocks noGrp="1"/>
-          </p:cNvGraphicFramePr>
-          <p:nvPr/>
-        </p:nvGraphicFramePr>
-        <p:xfrm>
-          <a:off x="365760" y="2456688"/>
-          <a:ext cx="8412479" cy="959103"/>
-        </p:xfrm>
-        <a:graphic>
-          <a:graphicData uri="http://schemas.openxmlformats.org/drawingml/2006/table">
-            <a:tbl>
-              <a:tblPr firstRow="1" bandRow="1">
-                <a:tableStyleId>{5C22544A-7EE6-4342-B048-85BDC9FD1C3A}</a:tableStyleId>
-              </a:tblPr>
-              <a:tblGrid>
-                <a:gridCol w="2271369"/>
-                <a:gridCol w="6141110"/>
-              </a:tblGrid>
-              <a:tr h="959103">
-                <a:tc>
-                  <a:txBody>
-                    <a:bodyPr wrap="none"/>
-                    <a:lstStyle/>
-                    <a:p>
-                      <a:pPr>
-                        <a:lnSpc>
-                          <a:spcPts val="1600"/>
-                        </a:lnSpc>
-                        <a:spcAft>
-                          <a:spcPts val="0"/>
-                        </a:spcAft>
-                        <a:defRPr sz="1200" b="0">
-                          <a:solidFill>
-                            <a:srgbClr val="21243A"/>
-                          </a:solidFill>
-                          <a:latin typeface="Arial"/>
-                        </a:defRPr>
-                      </a:pPr>
-                      <a:r>
-                        <a:t>Ingestion note 3</a:t>
-                      </a:r>
-                    </a:p>
-                  </a:txBody>
-                  <a:tcPr marL="82296" marR="82296" marT="64008" marB="64008">
-                    <a:solidFill>
-                      <a:srgbClr val="F1F7F7"/>
-                    </a:solidFill>
-                  </a:tcPr>
-                </a:tc>
-                <a:tc>
-                  <a:txBody>
-                    <a:bodyPr wrap="none"/>
-                    <a:lstStyle/>
-                    <a:p>
-                      <a:pPr>
-                        <a:lnSpc>
-                          <a:spcPts val="1600"/>
-                        </a:lnSpc>
-                        <a:spcAft>
-                          <a:spcPts val="0"/>
-                        </a:spcAft>
-                        <a:defRPr sz="1200" b="0">
-                          <a:solidFill>
-                            <a:srgbClr val="21243A"/>
-                          </a:solidFill>
-                          <a:latin typeface="Arial"/>
-                        </a:defRPr>
-                      </a:pPr>
-                      <a:r>
-                        <a:t>Presentation copy of saved report cf784e2f-0554-4bed-8880-c825ae7b8282. The</a:t>
-                      </a:r>
-                    </a:p>
-                    <a:p>
-                      <a:pPr>
-                        <a:lnSpc>
-                          <a:spcPts val="1600"/>
-                        </a:lnSpc>
-                        <a:spcAft>
-                          <a:spcPts val="0"/>
-                        </a:spcAft>
-                        <a:defRPr sz="1200" b="0">
-                          <a:solidFill>
-                            <a:srgbClr val="21243A"/>
-                          </a:solidFill>
-                          <a:latin typeface="Arial"/>
-                        </a:defRPr>
-                      </a:pPr>
-                      <a:r>
-                        <a:t>descriptive filename replaces the earlier example ID for navigation. Original</a:t>
-                      </a:r>
-                    </a:p>
-                    <a:p>
-                      <a:pPr>
-                        <a:lnSpc>
-                          <a:spcPts val="1600"/>
-                        </a:lnSpc>
-                        <a:spcAft>
-                          <a:spcPts val="0"/>
-                        </a:spcAft>
-                        <a:defRPr sz="1200" b="0">
-                          <a:solidFill>
-                            <a:srgbClr val="21243A"/>
-                          </a:solidFill>
-                          <a:latin typeface="Arial"/>
-                        </a:defRPr>
-                      </a:pPr>
-                      <a:r>
-                        <a:t>analysis dates, provider replies, scores and acquisition context are retained; no</a:t>
-                      </a:r>
-                    </a:p>
-                    <a:p>
-                      <a:pPr>
-                        <a:lnSpc>
-                          <a:spcPts val="1600"/>
-                        </a:lnSpc>
-                        <a:spcAft>
-                          <a:spcPts val="0"/>
-                        </a:spcAft>
-                        <a:defRPr sz="1200" b="0">
-                          <a:solidFill>
-                            <a:srgbClr val="21243A"/>
-                          </a:solidFill>
-                          <a:latin typeface="Arial"/>
-                        </a:defRPr>
-                      </a:pPr>
-                      <a:r>
-                        <a:t>new model analysis.</a:t>
-                      </a:r>
-                    </a:p>
-                  </a:txBody>
-                  <a:tcPr marL="82296" marR="82296" marT="64008" marB="64008">
-                    <a:solidFill>
-                      <a:srgbClr val="F1F7F7"/>
                     </a:solidFill>
                   </a:tcPr>
                 </a:tc>
@@ -12657,7 +12045,7 @@
                         </a:defRPr>
                       </a:pPr>
                       <a:r>
-                        <a:t>5/100</a:t>
+                        <a:t>4/100</a:t>
                       </a:r>
                     </a:p>
                   </a:txBody>
@@ -13552,7 +12940,7 @@
                         </a:defRPr>
                       </a:pPr>
                       <a:r>
-                        <a:t>5/100</a:t>
+                        <a:t>4/100</a:t>
                       </a:r>
                     </a:p>
                   </a:txBody>
@@ -13852,7 +13240,7 @@
                         </a:defRPr>
                       </a:pPr>
                       <a:r>
-                        <a:t>15/100</a:t>
+                        <a:t>25/100</a:t>
                       </a:r>
                     </a:p>
                   </a:txBody>
@@ -14979,7 +14367,7 @@
         </p:nvGraphicFramePr>
         <p:xfrm>
           <a:off x="365760" y="3797808"/>
-          <a:ext cx="8412479" cy="1162304"/>
+          <a:ext cx="8412479" cy="1365503"/>
         </p:xfrm>
         <a:graphic>
           <a:graphicData uri="http://schemas.openxmlformats.org/drawingml/2006/table">
@@ -14991,7 +14379,7 @@
                 <a:gridCol w="2271369"/>
                 <a:gridCol w="6141110"/>
               </a:tblGrid>
-              <a:tr h="1162304">
+              <a:tr h="1365503">
                 <a:tc>
                   <a:txBody>
                     <a:bodyPr wrap="none"/>
@@ -15042,83 +14430,102 @@
                         </a:defRPr>
                       </a:pPr>
                       <a:r>
-                        <a:t>synthetic likelihood 5/100; tells: composition matches the widely circulated 1972</a:t>
-                      </a:r>
-                    </a:p>
-                    <a:p>
-                      <a:pPr>
-                        <a:lnSpc>
-                          <a:spcPts val="1600"/>
-                        </a:lnSpc>
-                        <a:spcAft>
-                          <a:spcPts val="0"/>
-                        </a:spcAft>
-                        <a:defRPr sz="1200" b="0">
-                          <a:solidFill>
-                            <a:srgbClr val="21243A"/>
-                          </a:solidFill>
-                          <a:latin typeface="Arial"/>
-                        </a:defRPr>
-                      </a:pPr>
-                      <a:r>
-                        <a:t>Apollo 17 'Blue Marble' photograph (AS17-148-22727), geographically accurate</a:t>
-                      </a:r>
-                    </a:p>
-                    <a:p>
-                      <a:pPr>
-                        <a:lnSpc>
-                          <a:spcPts val="1600"/>
-                        </a:lnSpc>
-                        <a:spcAft>
-                          <a:spcPts val="0"/>
-                        </a:spcAft>
-                        <a:defRPr sz="1200" b="0">
-                          <a:solidFill>
-                            <a:srgbClr val="21243A"/>
-                          </a:solidFill>
-                          <a:latin typeface="Arial"/>
-                        </a:defRPr>
-                      </a:pPr>
-                      <a:r>
-                        <a:t>Africa, Arabian Peninsula, Red Sea, Gulf of Aden and Madagascar outlines,</a:t>
-                      </a:r>
-                    </a:p>
-                    <a:p>
-                      <a:pPr>
-                        <a:lnSpc>
-                          <a:spcPts val="1600"/>
-                        </a:lnSpc>
-                        <a:spcAft>
-                          <a:spcPts val="0"/>
-                        </a:spcAft>
-                        <a:defRPr sz="1200" b="0">
-                          <a:solidFill>
-                            <a:srgbClr val="21243A"/>
-                          </a:solidFill>
-                          <a:latin typeface="Arial"/>
-                        </a:defRPr>
-                      </a:pPr>
-                      <a:r>
-                        <a:t>Antarctic ice cap consistent with December solstice illumination, physically</a:t>
-                      </a:r>
-                    </a:p>
-                    <a:p>
-                      <a:pPr>
-                        <a:lnSpc>
-                          <a:spcPts val="1600"/>
-                        </a:lnSpc>
-                        <a:spcAft>
-                          <a:spcPts val="0"/>
-                        </a:spcAft>
-                        <a:defRPr sz="1200" b="0">
-                          <a:solidFill>
-                            <a:srgbClr val="21243A"/>
-                          </a:solidFill>
-                          <a:latin typeface="Arial"/>
-                        </a:defRPr>
-                      </a:pPr>
-                      <a:r>
-                        <a:t>coherent cloud structures: cyclonic swirls, frontal bands, open-cell cumulus fields</a:t>
+                        <a:t>synthetic likelihood 4/100; tells: visually consistent with the widely documented</a:t>
+                      </a:r>
+                    </a:p>
+                    <a:p>
+                      <a:pPr>
+                        <a:lnSpc>
+                          <a:spcPts val="1600"/>
+                        </a:lnSpc>
+                        <a:spcAft>
+                          <a:spcPts val="0"/>
+                        </a:spcAft>
+                        <a:defRPr sz="1200" b="0">
+                          <a:solidFill>
+                            <a:srgbClr val="21243A"/>
+                          </a:solidFill>
+                          <a:latin typeface="Arial"/>
+                        </a:defRPr>
+                      </a:pPr>
+                      <a:r>
+                        <a:t>Apollo 17 'Blue Marble' photograph (NASA AS17-148-22727, Dec 1972),</a:t>
+                      </a:r>
+                    </a:p>
+                    <a:p>
+                      <a:pPr>
+                        <a:lnSpc>
+                          <a:spcPts val="1600"/>
+                        </a:lnSpc>
+                        <a:spcAft>
+                          <a:spcPts val="0"/>
+                        </a:spcAft>
+                        <a:defRPr sz="1200" b="0">
+                          <a:solidFill>
+                            <a:srgbClr val="21243A"/>
+                          </a:solidFill>
+                          <a:latin typeface="Arial"/>
+                        </a:defRPr>
+                      </a:pPr>
+                      <a:r>
+                        <a:t>geographically accurate coastlines: Africa, Arabian Peninsula, Red Sea, Gulf of</a:t>
+                      </a:r>
+                    </a:p>
+                    <a:p>
+                      <a:pPr>
+                        <a:lnSpc>
+                          <a:spcPts val="1600"/>
+                        </a:lnSpc>
+                        <a:spcAft>
+                          <a:spcPts val="0"/>
+                        </a:spcAft>
+                        <a:defRPr sz="1200" b="0">
+                          <a:solidFill>
+                            <a:srgbClr val="21243A"/>
+                          </a:solidFill>
+                          <a:latin typeface="Arial"/>
+                        </a:defRPr>
+                      </a:pPr>
+                      <a:r>
+                        <a:t>Aden, Madagascar, Antarctic ice cap, physically coherent cloud systems and</a:t>
+                      </a:r>
+                    </a:p>
+                    <a:p>
+                      <a:pPr>
+                        <a:lnSpc>
+                          <a:spcPts val="1600"/>
+                        </a:lnSpc>
+                        <a:spcAft>
+                          <a:spcPts val="0"/>
+                        </a:spcAft>
+                        <a:defRPr sz="1200" b="0">
+                          <a:solidFill>
+                            <a:srgbClr val="21243A"/>
+                          </a:solidFill>
+                          <a:latin typeface="Arial"/>
+                        </a:defRPr>
+                      </a:pPr>
+                      <a:r>
+                        <a:t>cyclonic swirls with plausible meteorological structure, film-scan grain and slight</a:t>
+                      </a:r>
+                    </a:p>
+                    <a:p>
+                      <a:pPr>
+                        <a:lnSpc>
+                          <a:spcPts val="1600"/>
+                        </a:lnSpc>
+                        <a:spcAft>
+                          <a:spcPts val="0"/>
+                        </a:spcAft>
+                        <a:defRPr sz="1200" b="0">
+                          <a:solidFill>
+                            <a:srgbClr val="21243A"/>
+                          </a:solidFill>
+                          <a:latin typeface="Arial"/>
+                        </a:defRPr>
+                      </a:pPr>
+                      <a:r>
+                        <a:t>color cast consistent with analog photography</a:t>
                       </a:r>
                     </a:p>
                   </a:txBody>
@@ -15142,7 +14549,7 @@
           <p:nvPr/>
         </p:nvGraphicFramePr>
         <p:xfrm>
-          <a:off x="365760" y="4960112"/>
+          <a:off x="365760" y="5163312"/>
           <a:ext cx="8412479" cy="552704"/>
         </p:xfrm>
         <a:graphic>
@@ -15206,139 +14613,32 @@
                         </a:defRPr>
                       </a:pPr>
                       <a:r>
-                        <a:t>Composition matches the widely circulated 1972 Apollo 17 'Blue Marble'</a:t>
-                      </a:r>
-                    </a:p>
-                    <a:p>
-                      <a:pPr>
-                        <a:lnSpc>
-                          <a:spcPts val="1600"/>
-                        </a:lnSpc>
-                        <a:spcAft>
-                          <a:spcPts val="0"/>
-                        </a:spcAft>
-                        <a:defRPr sz="1200" b="0">
-                          <a:solidFill>
-                            <a:srgbClr val="21243A"/>
-                          </a:solidFill>
-                          <a:latin typeface="Arial"/>
-                        </a:defRPr>
-                      </a:pPr>
-                      <a:r>
-                        <a:t>photograph (AS17-148-22727)</a:t>
+                        <a:t>Visually consistent with the widely documented Apollo 17 'Blue Marble'</a:t>
+                      </a:r>
+                    </a:p>
+                    <a:p>
+                      <a:pPr>
+                        <a:lnSpc>
+                          <a:spcPts val="1600"/>
+                        </a:lnSpc>
+                        <a:spcAft>
+                          <a:spcPts val="0"/>
+                        </a:spcAft>
+                        <a:defRPr sz="1200" b="0">
+                          <a:solidFill>
+                            <a:srgbClr val="21243A"/>
+                          </a:solidFill>
+                          <a:latin typeface="Arial"/>
+                        </a:defRPr>
+                      </a:pPr>
+                      <a:r>
+                        <a:t>photograph (NASA AS17-148-22727, Dec 1972)</a:t>
                       </a:r>
                     </a:p>
                   </a:txBody>
                   <a:tcPr marL="82296" marR="82296" marT="64008" marB="64008">
                     <a:solidFill>
                       <a:srgbClr val="FFFFFF"/>
-                    </a:solidFill>
-                  </a:tcPr>
-                </a:tc>
-              </a:tr>
-            </a:tbl>
-          </a:graphicData>
-        </a:graphic>
-      </p:graphicFrame>
-      <p:graphicFrame>
-        <p:nvGraphicFramePr>
-          <p:cNvPr id="15" name="Table 14"/>
-          <p:cNvGraphicFramePr>
-            <a:graphicFrameLocks noGrp="1"/>
-          </p:cNvGraphicFramePr>
-          <p:nvPr/>
-        </p:nvGraphicFramePr>
-        <p:xfrm>
-          <a:off x="365760" y="5512816"/>
-          <a:ext cx="8412479" cy="552704"/>
-        </p:xfrm>
-        <a:graphic>
-          <a:graphicData uri="http://schemas.openxmlformats.org/drawingml/2006/table">
-            <a:tbl>
-              <a:tblPr firstRow="1" bandRow="1">
-                <a:tableStyleId>{5C22544A-7EE6-4342-B048-85BDC9FD1C3A}</a:tableStyleId>
-              </a:tblPr>
-              <a:tblGrid>
-                <a:gridCol w="2271369"/>
-                <a:gridCol w="6141110"/>
-              </a:tblGrid>
-              <a:tr h="552704">
-                <a:tc>
-                  <a:txBody>
-                    <a:bodyPr wrap="none"/>
-                    <a:lstStyle/>
-                    <a:p>
-                      <a:pPr>
-                        <a:lnSpc>
-                          <a:spcPts val="1600"/>
-                        </a:lnSpc>
-                        <a:spcAft>
-                          <a:spcPts val="0"/>
-                        </a:spcAft>
-                        <a:defRPr sz="1200" b="0">
-                          <a:solidFill>
-                            <a:srgbClr val="21243A"/>
-                          </a:solidFill>
-                          <a:latin typeface="Arial"/>
-                        </a:defRPr>
-                      </a:pPr>
-                      <a:r>
-                        <a:t>Evidence 2</a:t>
-                      </a:r>
-                    </a:p>
-                  </a:txBody>
-                  <a:tcPr marL="82296" marR="82296" marT="64008" marB="64008">
-                    <a:solidFill>
-                      <a:srgbClr val="F1F7F7"/>
-                    </a:solidFill>
-                  </a:tcPr>
-                </a:tc>
-                <a:tc>
-                  <a:txBody>
-                    <a:bodyPr wrap="none"/>
-                    <a:lstStyle/>
-                    <a:p>
-                      <a:pPr>
-                        <a:lnSpc>
-                          <a:spcPts val="1600"/>
-                        </a:lnSpc>
-                        <a:spcAft>
-                          <a:spcPts val="0"/>
-                        </a:spcAft>
-                        <a:defRPr sz="1200" b="0">
-                          <a:solidFill>
-                            <a:srgbClr val="21243A"/>
-                          </a:solidFill>
-                          <a:latin typeface="Arial"/>
-                        </a:defRPr>
-                      </a:pPr>
-                      <a:r>
-                        <a:t>Geographically accurate Africa, Arabian Peninsula, Red Sea, Gulf of Aden and</a:t>
-                      </a:r>
-                    </a:p>
-                    <a:p>
-                      <a:pPr>
-                        <a:lnSpc>
-                          <a:spcPts val="1600"/>
-                        </a:lnSpc>
-                        <a:spcAft>
-                          <a:spcPts val="0"/>
-                        </a:spcAft>
-                        <a:defRPr sz="1200" b="0">
-                          <a:solidFill>
-                            <a:srgbClr val="21243A"/>
-                          </a:solidFill>
-                          <a:latin typeface="Arial"/>
-                        </a:defRPr>
-                      </a:pPr>
-                      <a:r>
-                        <a:t>Madagascar outlines</a:t>
-                      </a:r>
-                    </a:p>
-                  </a:txBody>
-                  <a:tcPr marL="82296" marR="82296" marT="64008" marB="64008">
-                    <a:solidFill>
-                      <a:srgbClr val="F1F7F7"/>
                     </a:solidFill>
                   </a:tcPr>
                 </a:tc>
@@ -15631,7 +14931,7 @@
         </p:nvGraphicFramePr>
         <p:xfrm>
           <a:off x="365760" y="1700784"/>
-          <a:ext cx="8412479" cy="349504"/>
+          <a:ext cx="8412479" cy="552704"/>
         </p:xfrm>
         <a:graphic>
           <a:graphicData uri="http://schemas.openxmlformats.org/drawingml/2006/table">
@@ -15643,64 +14943,83 @@
                 <a:gridCol w="2271369"/>
                 <a:gridCol w="6141110"/>
               </a:tblGrid>
-              <a:tr h="349504">
-                <a:tc>
-                  <a:txBody>
-                    <a:bodyPr wrap="none"/>
-                    <a:lstStyle/>
-                    <a:p>
-                      <a:pPr>
-                        <a:lnSpc>
-                          <a:spcPts val="1600"/>
-                        </a:lnSpc>
-                        <a:spcAft>
-                          <a:spcPts val="0"/>
-                        </a:spcAft>
-                        <a:defRPr sz="1200" b="0">
-                          <a:solidFill>
-                            <a:srgbClr val="21243A"/>
-                          </a:solidFill>
-                          <a:latin typeface="Arial"/>
-                        </a:defRPr>
-                      </a:pPr>
-                      <a:r>
-                        <a:t>Evidence 3</a:t>
-                      </a:r>
-                    </a:p>
-                  </a:txBody>
-                  <a:tcPr marL="82296" marR="82296" marT="64008" marB="64008">
-                    <a:solidFill>
-                      <a:srgbClr val="FFFFFF"/>
-                    </a:solidFill>
-                  </a:tcPr>
-                </a:tc>
-                <a:tc>
-                  <a:txBody>
-                    <a:bodyPr wrap="none"/>
-                    <a:lstStyle/>
-                    <a:p>
-                      <a:pPr>
-                        <a:lnSpc>
-                          <a:spcPts val="1600"/>
-                        </a:lnSpc>
-                        <a:spcAft>
-                          <a:spcPts val="0"/>
-                        </a:spcAft>
-                        <a:defRPr sz="1200" b="0">
-                          <a:solidFill>
-                            <a:srgbClr val="21243A"/>
-                          </a:solidFill>
-                          <a:latin typeface="Arial"/>
-                        </a:defRPr>
-                      </a:pPr>
-                      <a:r>
-                        <a:t>Antarctic ice cap consistent with December solstice illumination</a:t>
-                      </a:r>
-                    </a:p>
-                  </a:txBody>
-                  <a:tcPr marL="82296" marR="82296" marT="64008" marB="64008">
-                    <a:solidFill>
-                      <a:srgbClr val="FFFFFF"/>
+              <a:tr h="552704">
+                <a:tc>
+                  <a:txBody>
+                    <a:bodyPr wrap="none"/>
+                    <a:lstStyle/>
+                    <a:p>
+                      <a:pPr>
+                        <a:lnSpc>
+                          <a:spcPts val="1600"/>
+                        </a:lnSpc>
+                        <a:spcAft>
+                          <a:spcPts val="0"/>
+                        </a:spcAft>
+                        <a:defRPr sz="1200" b="0">
+                          <a:solidFill>
+                            <a:srgbClr val="21243A"/>
+                          </a:solidFill>
+                          <a:latin typeface="Arial"/>
+                        </a:defRPr>
+                      </a:pPr>
+                      <a:r>
+                        <a:t>Evidence 2</a:t>
+                      </a:r>
+                    </a:p>
+                  </a:txBody>
+                  <a:tcPr marL="82296" marR="82296" marT="64008" marB="64008">
+                    <a:solidFill>
+                      <a:srgbClr val="F1F7F7"/>
+                    </a:solidFill>
+                  </a:tcPr>
+                </a:tc>
+                <a:tc>
+                  <a:txBody>
+                    <a:bodyPr wrap="none"/>
+                    <a:lstStyle/>
+                    <a:p>
+                      <a:pPr>
+                        <a:lnSpc>
+                          <a:spcPts val="1600"/>
+                        </a:lnSpc>
+                        <a:spcAft>
+                          <a:spcPts val="0"/>
+                        </a:spcAft>
+                        <a:defRPr sz="1200" b="0">
+                          <a:solidFill>
+                            <a:srgbClr val="21243A"/>
+                          </a:solidFill>
+                          <a:latin typeface="Arial"/>
+                        </a:defRPr>
+                      </a:pPr>
+                      <a:r>
+                        <a:t>Geographically accurate coastlines: Africa, Arabian Peninsula, Red Sea, Gulf of</a:t>
+                      </a:r>
+                    </a:p>
+                    <a:p>
+                      <a:pPr>
+                        <a:lnSpc>
+                          <a:spcPts val="1600"/>
+                        </a:lnSpc>
+                        <a:spcAft>
+                          <a:spcPts val="0"/>
+                        </a:spcAft>
+                        <a:defRPr sz="1200" b="0">
+                          <a:solidFill>
+                            <a:srgbClr val="21243A"/>
+                          </a:solidFill>
+                          <a:latin typeface="Arial"/>
+                        </a:defRPr>
+                      </a:pPr>
+                      <a:r>
+                        <a:t>Aden, Madagascar, Antarctic ice cap</a:t>
+                      </a:r>
+                    </a:p>
+                  </a:txBody>
+                  <a:tcPr marL="82296" marR="82296" marT="64008" marB="64008">
+                    <a:solidFill>
+                      <a:srgbClr val="F1F7F7"/>
                     </a:solidFill>
                   </a:tcPr>
                 </a:tc>
@@ -15718,7 +15037,7 @@
           <p:nvPr/>
         </p:nvGraphicFramePr>
         <p:xfrm>
-          <a:off x="365760" y="2050288"/>
+          <a:off x="365760" y="2253488"/>
           <a:ext cx="8412479" cy="552704"/>
         </p:xfrm>
         <a:graphic>
@@ -15752,62 +15071,62 @@
                         </a:defRPr>
                       </a:pPr>
                       <a:r>
-                        <a:t>Evidence 4</a:t>
-                      </a:r>
-                    </a:p>
-                  </a:txBody>
-                  <a:tcPr marL="82296" marR="82296" marT="64008" marB="64008">
-                    <a:solidFill>
-                      <a:srgbClr val="F1F7F7"/>
-                    </a:solidFill>
-                  </a:tcPr>
-                </a:tc>
-                <a:tc>
-                  <a:txBody>
-                    <a:bodyPr wrap="none"/>
-                    <a:lstStyle/>
-                    <a:p>
-                      <a:pPr>
-                        <a:lnSpc>
-                          <a:spcPts val="1600"/>
-                        </a:lnSpc>
-                        <a:spcAft>
-                          <a:spcPts val="0"/>
-                        </a:spcAft>
-                        <a:defRPr sz="1200" b="0">
-                          <a:solidFill>
-                            <a:srgbClr val="21243A"/>
-                          </a:solidFill>
-                          <a:latin typeface="Arial"/>
-                        </a:defRPr>
-                      </a:pPr>
-                      <a:r>
-                        <a:t>Physically coherent cloud structures: cyclonic swirls, frontal bands, open-cell</a:t>
-                      </a:r>
-                    </a:p>
-                    <a:p>
-                      <a:pPr>
-                        <a:lnSpc>
-                          <a:spcPts val="1600"/>
-                        </a:lnSpc>
-                        <a:spcAft>
-                          <a:spcPts val="0"/>
-                        </a:spcAft>
-                        <a:defRPr sz="1200" b="0">
-                          <a:solidFill>
-                            <a:srgbClr val="21243A"/>
-                          </a:solidFill>
-                          <a:latin typeface="Arial"/>
-                        </a:defRPr>
-                      </a:pPr>
-                      <a:r>
-                        <a:t>cumulus fields</a:t>
-                      </a:r>
-                    </a:p>
-                  </a:txBody>
-                  <a:tcPr marL="82296" marR="82296" marT="64008" marB="64008">
-                    <a:solidFill>
-                      <a:srgbClr val="F1F7F7"/>
+                        <a:t>Evidence 3</a:t>
+                      </a:r>
+                    </a:p>
+                  </a:txBody>
+                  <a:tcPr marL="82296" marR="82296" marT="64008" marB="64008">
+                    <a:solidFill>
+                      <a:srgbClr val="FFFFFF"/>
+                    </a:solidFill>
+                  </a:tcPr>
+                </a:tc>
+                <a:tc>
+                  <a:txBody>
+                    <a:bodyPr wrap="none"/>
+                    <a:lstStyle/>
+                    <a:p>
+                      <a:pPr>
+                        <a:lnSpc>
+                          <a:spcPts val="1600"/>
+                        </a:lnSpc>
+                        <a:spcAft>
+                          <a:spcPts val="0"/>
+                        </a:spcAft>
+                        <a:defRPr sz="1200" b="0">
+                          <a:solidFill>
+                            <a:srgbClr val="21243A"/>
+                          </a:solidFill>
+                          <a:latin typeface="Arial"/>
+                        </a:defRPr>
+                      </a:pPr>
+                      <a:r>
+                        <a:t>Physically coherent cloud systems and cyclonic swirls with plausible</a:t>
+                      </a:r>
+                    </a:p>
+                    <a:p>
+                      <a:pPr>
+                        <a:lnSpc>
+                          <a:spcPts val="1600"/>
+                        </a:lnSpc>
+                        <a:spcAft>
+                          <a:spcPts val="0"/>
+                        </a:spcAft>
+                        <a:defRPr sz="1200" b="0">
+                          <a:solidFill>
+                            <a:srgbClr val="21243A"/>
+                          </a:solidFill>
+                          <a:latin typeface="Arial"/>
+                        </a:defRPr>
+                      </a:pPr>
+                      <a:r>
+                        <a:t>meteorological structure</a:t>
+                      </a:r>
+                    </a:p>
+                  </a:txBody>
+                  <a:tcPr marL="82296" marR="82296" marT="64008" marB="64008">
+                    <a:solidFill>
+                      <a:srgbClr val="FFFFFF"/>
                     </a:solidFill>
                   </a:tcPr>
                 </a:tc>
@@ -15825,8 +15144,8 @@
           <p:nvPr/>
         </p:nvGraphicFramePr>
         <p:xfrm>
-          <a:off x="365760" y="2602992"/>
-          <a:ext cx="8412479" cy="552704"/>
+          <a:off x="365760" y="2806192"/>
+          <a:ext cx="8412479" cy="349504"/>
         </p:xfrm>
         <a:graphic>
           <a:graphicData uri="http://schemas.openxmlformats.org/drawingml/2006/table">
@@ -15838,83 +15157,64 @@
                 <a:gridCol w="2271369"/>
                 <a:gridCol w="6141110"/>
               </a:tblGrid>
-              <a:tr h="552704">
-                <a:tc>
-                  <a:txBody>
-                    <a:bodyPr wrap="none"/>
-                    <a:lstStyle/>
-                    <a:p>
-                      <a:pPr>
-                        <a:lnSpc>
-                          <a:spcPts val="1600"/>
-                        </a:lnSpc>
-                        <a:spcAft>
-                          <a:spcPts val="0"/>
-                        </a:spcAft>
-                        <a:defRPr sz="1200" b="0">
-                          <a:solidFill>
-                            <a:srgbClr val="21243A"/>
-                          </a:solidFill>
-                          <a:latin typeface="Arial"/>
-                        </a:defRPr>
-                      </a:pPr>
-                      <a:r>
-                        <a:t>Evidence 5</a:t>
-                      </a:r>
-                    </a:p>
-                  </a:txBody>
-                  <a:tcPr marL="82296" marR="82296" marT="64008" marB="64008">
-                    <a:solidFill>
-                      <a:srgbClr val="FFFFFF"/>
-                    </a:solidFill>
-                  </a:tcPr>
-                </a:tc>
-                <a:tc>
-                  <a:txBody>
-                    <a:bodyPr wrap="none"/>
-                    <a:lstStyle/>
-                    <a:p>
-                      <a:pPr>
-                        <a:lnSpc>
-                          <a:spcPts val="1600"/>
-                        </a:lnSpc>
-                        <a:spcAft>
-                          <a:spcPts val="0"/>
-                        </a:spcAft>
-                        <a:defRPr sz="1200" b="0">
-                          <a:solidFill>
-                            <a:srgbClr val="21243A"/>
-                          </a:solidFill>
-                          <a:latin typeface="Arial"/>
-                        </a:defRPr>
-                      </a:pPr>
-                      <a:r>
-                        <a:t>Film-scan grain and slight color cast consistent with analog Hasselblad film</a:t>
-                      </a:r>
-                    </a:p>
-                    <a:p>
-                      <a:pPr>
-                        <a:lnSpc>
-                          <a:spcPts val="1600"/>
-                        </a:lnSpc>
-                        <a:spcAft>
-                          <a:spcPts val="0"/>
-                        </a:spcAft>
-                        <a:defRPr sz="1200" b="0">
-                          <a:solidFill>
-                            <a:srgbClr val="21243A"/>
-                          </a:solidFill>
-                          <a:latin typeface="Arial"/>
-                        </a:defRPr>
-                      </a:pPr>
-                      <a:r>
-                        <a:t>digitization</a:t>
-                      </a:r>
-                    </a:p>
-                  </a:txBody>
-                  <a:tcPr marL="82296" marR="82296" marT="64008" marB="64008">
-                    <a:solidFill>
-                      <a:srgbClr val="FFFFFF"/>
+              <a:tr h="349504">
+                <a:tc>
+                  <a:txBody>
+                    <a:bodyPr wrap="none"/>
+                    <a:lstStyle/>
+                    <a:p>
+                      <a:pPr>
+                        <a:lnSpc>
+                          <a:spcPts val="1600"/>
+                        </a:lnSpc>
+                        <a:spcAft>
+                          <a:spcPts val="0"/>
+                        </a:spcAft>
+                        <a:defRPr sz="1200" b="0">
+                          <a:solidFill>
+                            <a:srgbClr val="21243A"/>
+                          </a:solidFill>
+                          <a:latin typeface="Arial"/>
+                        </a:defRPr>
+                      </a:pPr>
+                      <a:r>
+                        <a:t>Evidence 4</a:t>
+                      </a:r>
+                    </a:p>
+                  </a:txBody>
+                  <a:tcPr marL="82296" marR="82296" marT="64008" marB="64008">
+                    <a:solidFill>
+                      <a:srgbClr val="F1F7F7"/>
+                    </a:solidFill>
+                  </a:tcPr>
+                </a:tc>
+                <a:tc>
+                  <a:txBody>
+                    <a:bodyPr wrap="none"/>
+                    <a:lstStyle/>
+                    <a:p>
+                      <a:pPr>
+                        <a:lnSpc>
+                          <a:spcPts val="1600"/>
+                        </a:lnSpc>
+                        <a:spcAft>
+                          <a:spcPts val="0"/>
+                        </a:spcAft>
+                        <a:defRPr sz="1200" b="0">
+                          <a:solidFill>
+                            <a:srgbClr val="21243A"/>
+                          </a:solidFill>
+                          <a:latin typeface="Arial"/>
+                        </a:defRPr>
+                      </a:pPr>
+                      <a:r>
+                        <a:t>Film-scan grain and slight color cast consistent with analog photography</a:t>
+                      </a:r>
+                    </a:p>
+                  </a:txBody>
+                  <a:tcPr marL="82296" marR="82296" marT="64008" marB="64008">
+                    <a:solidFill>
+                      <a:srgbClr val="F1F7F7"/>
                     </a:solidFill>
                   </a:tcPr>
                 </a:tc>
@@ -15933,7 +15233,7 @@
         </p:nvGraphicFramePr>
         <p:xfrm>
           <a:off x="365760" y="3155696"/>
-          <a:ext cx="8412479" cy="349504"/>
+          <a:ext cx="8412479" cy="552704"/>
         </p:xfrm>
         <a:graphic>
           <a:graphicData uri="http://schemas.openxmlformats.org/drawingml/2006/table">
@@ -15945,64 +15245,83 @@
                 <a:gridCol w="2271369"/>
                 <a:gridCol w="6141110"/>
               </a:tblGrid>
-              <a:tr h="349504">
-                <a:tc>
-                  <a:txBody>
-                    <a:bodyPr wrap="none"/>
-                    <a:lstStyle/>
-                    <a:p>
-                      <a:pPr>
-                        <a:lnSpc>
-                          <a:spcPts val="1600"/>
-                        </a:lnSpc>
-                        <a:spcAft>
-                          <a:spcPts val="0"/>
-                        </a:spcAft>
-                        <a:defRPr sz="1200" b="0">
-                          <a:solidFill>
-                            <a:srgbClr val="21243A"/>
-                          </a:solidFill>
-                          <a:latin typeface="Arial"/>
-                        </a:defRPr>
-                      </a:pPr>
-                      <a:r>
-                        <a:t>Evidence 6</a:t>
-                      </a:r>
-                    </a:p>
-                  </a:txBody>
-                  <a:tcPr marL="82296" marR="82296" marT="64008" marB="64008">
-                    <a:solidFill>
-                      <a:srgbClr val="F1F7F7"/>
-                    </a:solidFill>
-                  </a:tcPr>
-                </a:tc>
-                <a:tc>
-                  <a:txBody>
-                    <a:bodyPr wrap="none"/>
-                    <a:lstStyle/>
-                    <a:p>
-                      <a:pPr>
-                        <a:lnSpc>
-                          <a:spcPts val="1600"/>
-                        </a:lnSpc>
-                        <a:spcAft>
-                          <a:spcPts val="0"/>
-                        </a:spcAft>
-                        <a:defRPr sz="1200" b="0">
-                          <a:solidFill>
-                            <a:srgbClr val="21243A"/>
-                          </a:solidFill>
-                          <a:latin typeface="Arial"/>
-                        </a:defRPr>
-                      </a:pPr>
-                      <a:r>
-                        <a:t>Natural limb darkening and atmospheric haze at globe edge</a:t>
-                      </a:r>
-                    </a:p>
-                  </a:txBody>
-                  <a:tcPr marL="82296" marR="82296" marT="64008" marB="64008">
-                    <a:solidFill>
-                      <a:srgbClr val="F1F7F7"/>
+              <a:tr h="552704">
+                <a:tc>
+                  <a:txBody>
+                    <a:bodyPr wrap="none"/>
+                    <a:lstStyle/>
+                    <a:p>
+                      <a:pPr>
+                        <a:lnSpc>
+                          <a:spcPts val="1600"/>
+                        </a:lnSpc>
+                        <a:spcAft>
+                          <a:spcPts val="0"/>
+                        </a:spcAft>
+                        <a:defRPr sz="1200" b="0">
+                          <a:solidFill>
+                            <a:srgbClr val="21243A"/>
+                          </a:solidFill>
+                          <a:latin typeface="Arial"/>
+                        </a:defRPr>
+                      </a:pPr>
+                      <a:r>
+                        <a:t>Evidence 5</a:t>
+                      </a:r>
+                    </a:p>
+                  </a:txBody>
+                  <a:tcPr marL="82296" marR="82296" marT="64008" marB="64008">
+                    <a:solidFill>
+                      <a:srgbClr val="FFFFFF"/>
+                    </a:solidFill>
+                  </a:tcPr>
+                </a:tc>
+                <a:tc>
+                  <a:txBody>
+                    <a:bodyPr wrap="none"/>
+                    <a:lstStyle/>
+                    <a:p>
+                      <a:pPr>
+                        <a:lnSpc>
+                          <a:spcPts val="1600"/>
+                        </a:lnSpc>
+                        <a:spcAft>
+                          <a:spcPts val="0"/>
+                        </a:spcAft>
+                        <a:defRPr sz="1200" b="0">
+                          <a:solidFill>
+                            <a:srgbClr val="21243A"/>
+                          </a:solidFill>
+                          <a:latin typeface="Arial"/>
+                        </a:defRPr>
+                      </a:pPr>
+                      <a:r>
+                        <a:t>Natural limb shading and terminator-free full-disc illumination consistent with sun</a:t>
+                      </a:r>
+                    </a:p>
+                    <a:p>
+                      <a:pPr>
+                        <a:lnSpc>
+                          <a:spcPts val="1600"/>
+                        </a:lnSpc>
+                        <a:spcAft>
+                          <a:spcPts val="0"/>
+                        </a:spcAft>
+                        <a:defRPr sz="1200" b="0">
+                          <a:solidFill>
+                            <a:srgbClr val="21243A"/>
+                          </a:solidFill>
+                          <a:latin typeface="Arial"/>
+                        </a:defRPr>
+                      </a:pPr>
+                      <a:r>
+                        <a:t>behind the camera</a:t>
+                      </a:r>
+                    </a:p>
+                  </a:txBody>
+                  <a:tcPr marL="82296" marR="82296" marT="64008" marB="64008">
+                    <a:solidFill>
+                      <a:srgbClr val="FFFFFF"/>
                     </a:solidFill>
                   </a:tcPr>
                 </a:tc>
@@ -16020,7 +15339,7 @@
           <p:nvPr/>
         </p:nvGraphicFramePr>
         <p:xfrm>
-          <a:off x="365760" y="3505199"/>
+          <a:off x="365760" y="3708400"/>
           <a:ext cx="8412479" cy="552704"/>
         </p:xfrm>
         <a:graphic>
@@ -16054,62 +15373,62 @@
                         </a:defRPr>
                       </a:pPr>
                       <a:r>
-                        <a:t>Evidence 7</a:t>
-                      </a:r>
-                    </a:p>
-                  </a:txBody>
-                  <a:tcPr marL="82296" marR="82296" marT="64008" marB="64008">
-                    <a:solidFill>
-                      <a:srgbClr val="FFFFFF"/>
-                    </a:solidFill>
-                  </a:tcPr>
-                </a:tc>
-                <a:tc>
-                  <a:txBody>
-                    <a:bodyPr wrap="none"/>
-                    <a:lstStyle/>
-                    <a:p>
-                      <a:pPr>
-                        <a:lnSpc>
-                          <a:spcPts val="1600"/>
-                        </a:lnSpc>
-                        <a:spcAft>
-                          <a:spcPts val="0"/>
-                        </a:spcAft>
-                        <a:defRPr sz="1200" b="0">
-                          <a:solidFill>
-                            <a:srgbClr val="21243A"/>
-                          </a:solidFill>
-                          <a:latin typeface="Arial"/>
-                        </a:defRPr>
-                      </a:pPr>
-                      <a:r>
-                        <a:t>No repeating textures, smeared regions or implausible landmass shapes typical of</a:t>
-                      </a:r>
-                    </a:p>
-                    <a:p>
-                      <a:pPr>
-                        <a:lnSpc>
-                          <a:spcPts val="1600"/>
-                        </a:lnSpc>
-                        <a:spcAft>
-                          <a:spcPts val="0"/>
-                        </a:spcAft>
-                        <a:defRPr sz="1200" b="0">
-                          <a:solidFill>
-                            <a:srgbClr val="21243A"/>
-                          </a:solidFill>
-                          <a:latin typeface="Arial"/>
-                        </a:defRPr>
-                      </a:pPr>
-                      <a:r>
-                        <a:t>generative models</a:t>
-                      </a:r>
-                    </a:p>
-                  </a:txBody>
-                  <a:tcPr marL="82296" marR="82296" marT="64008" marB="64008">
-                    <a:solidFill>
-                      <a:srgbClr val="FFFFFF"/>
+                        <a:t>Evidence 6</a:t>
+                      </a:r>
+                    </a:p>
+                  </a:txBody>
+                  <a:tcPr marL="82296" marR="82296" marT="64008" marB="64008">
+                    <a:solidFill>
+                      <a:srgbClr val="F1F7F7"/>
+                    </a:solidFill>
+                  </a:tcPr>
+                </a:tc>
+                <a:tc>
+                  <a:txBody>
+                    <a:bodyPr wrap="none"/>
+                    <a:lstStyle/>
+                    <a:p>
+                      <a:pPr>
+                        <a:lnSpc>
+                          <a:spcPts val="1600"/>
+                        </a:lnSpc>
+                        <a:spcAft>
+                          <a:spcPts val="0"/>
+                        </a:spcAft>
+                        <a:defRPr sz="1200" b="0">
+                          <a:solidFill>
+                            <a:srgbClr val="21243A"/>
+                          </a:solidFill>
+                          <a:latin typeface="Arial"/>
+                        </a:defRPr>
+                      </a:pPr>
+                      <a:r>
+                        <a:t>No repeated textures, smeared detail, or generative blending artifacts at</a:t>
+                      </a:r>
+                    </a:p>
+                    <a:p>
+                      <a:pPr>
+                        <a:lnSpc>
+                          <a:spcPts val="1600"/>
+                        </a:lnSpc>
+                        <a:spcAft>
+                          <a:spcPts val="0"/>
+                        </a:spcAft>
+                        <a:defRPr sz="1200" b="0">
+                          <a:solidFill>
+                            <a:srgbClr val="21243A"/>
+                          </a:solidFill>
+                          <a:latin typeface="Arial"/>
+                        </a:defRPr>
+                      </a:pPr>
+                      <a:r>
+                        <a:t>land/cloud boundaries</a:t>
+                      </a:r>
+                    </a:p>
+                  </a:txBody>
+                  <a:tcPr marL="82296" marR="82296" marT="64008" marB="64008">
+                    <a:solidFill>
+                      <a:srgbClr val="F1F7F7"/>
                     </a:solidFill>
                   </a:tcPr>
                 </a:tc>
@@ -16127,8 +15446,8 @@
           <p:nvPr/>
         </p:nvGraphicFramePr>
         <p:xfrm>
-          <a:off x="365760" y="4057904"/>
-          <a:ext cx="8412479" cy="755904"/>
+          <a:off x="365760" y="4261104"/>
+          <a:ext cx="8412479" cy="959103"/>
         </p:xfrm>
         <a:graphic>
           <a:graphicData uri="http://schemas.openxmlformats.org/drawingml/2006/table">
@@ -16140,102 +15459,121 @@
                 <a:gridCol w="2271369"/>
                 <a:gridCol w="6141110"/>
               </a:tblGrid>
-              <a:tr h="755904">
-                <a:tc>
-                  <a:txBody>
-                    <a:bodyPr wrap="none"/>
-                    <a:lstStyle/>
-                    <a:p>
-                      <a:pPr>
-                        <a:lnSpc>
-                          <a:spcPts val="1600"/>
-                        </a:lnSpc>
-                        <a:spcAft>
-                          <a:spcPts val="0"/>
-                        </a:spcAft>
-                        <a:defRPr sz="1200" b="0">
-                          <a:solidFill>
-                            <a:srgbClr val="21243A"/>
-                          </a:solidFill>
-                          <a:latin typeface="Arial"/>
-                        </a:defRPr>
-                      </a:pPr>
-                      <a:r>
-                        <a:t>Evidence 8</a:t>
-                      </a:r>
-                    </a:p>
-                  </a:txBody>
-                  <a:tcPr marL="82296" marR="82296" marT="64008" marB="64008">
-                    <a:solidFill>
-                      <a:srgbClr val="F1F7F7"/>
-                    </a:solidFill>
-                  </a:tcPr>
-                </a:tc>
-                <a:tc>
-                  <a:txBody>
-                    <a:bodyPr wrap="none"/>
-                    <a:lstStyle/>
-                    <a:p>
-                      <a:pPr>
-                        <a:lnSpc>
-                          <a:spcPts val="1600"/>
-                        </a:lnSpc>
-                        <a:spcAft>
-                          <a:spcPts val="0"/>
-                        </a:spcAft>
-                        <a:defRPr sz="1200" b="0">
-                          <a:solidFill>
-                            <a:srgbClr val="21243A"/>
-                          </a:solidFill>
-                          <a:latin typeface="Arial"/>
-                        </a:defRPr>
-                      </a:pPr>
-                      <a:r>
-                        <a:t>Caveat: Visual match to a famous archival photo is strong, but a high-quality AI</a:t>
-                      </a:r>
-                    </a:p>
-                    <a:p>
-                      <a:pPr>
-                        <a:lnSpc>
-                          <a:spcPts val="1600"/>
-                        </a:lnSpc>
-                        <a:spcAft>
-                          <a:spcPts val="0"/>
-                        </a:spcAft>
-                        <a:defRPr sz="1200" b="0">
-                          <a:solidFill>
-                            <a:srgbClr val="21243A"/>
-                          </a:solidFill>
-                          <a:latin typeface="Arial"/>
-                        </a:defRPr>
-                      </a:pPr>
-                      <a:r>
-                        <a:t>recreation or a color-adjusted/re-edited version could look similar; confirm via</a:t>
-                      </a:r>
-                    </a:p>
-                    <a:p>
-                      <a:pPr>
-                        <a:lnSpc>
-                          <a:spcPts val="1600"/>
-                        </a:lnSpc>
-                        <a:spcAft>
-                          <a:spcPts val="0"/>
-                        </a:spcAft>
-                        <a:defRPr sz="1200" b="0">
-                          <a:solidFill>
-                            <a:srgbClr val="21243A"/>
-                          </a:solidFill>
-                          <a:latin typeface="Arial"/>
-                        </a:defRPr>
-                      </a:pPr>
-                      <a:r>
-                        <a:t>reverse image search against the NASA archive original and check file metadata.</a:t>
-                      </a:r>
-                    </a:p>
-                  </a:txBody>
-                  <a:tcPr marL="82296" marR="82296" marT="64008" marB="64008">
-                    <a:solidFill>
-                      <a:srgbClr val="F1F7F7"/>
+              <a:tr h="959103">
+                <a:tc>
+                  <a:txBody>
+                    <a:bodyPr wrap="none"/>
+                    <a:lstStyle/>
+                    <a:p>
+                      <a:pPr>
+                        <a:lnSpc>
+                          <a:spcPts val="1600"/>
+                        </a:lnSpc>
+                        <a:spcAft>
+                          <a:spcPts val="0"/>
+                        </a:spcAft>
+                        <a:defRPr sz="1200" b="0">
+                          <a:solidFill>
+                            <a:srgbClr val="21243A"/>
+                          </a:solidFill>
+                          <a:latin typeface="Arial"/>
+                        </a:defRPr>
+                      </a:pPr>
+                      <a:r>
+                        <a:t>Evidence 7</a:t>
+                      </a:r>
+                    </a:p>
+                  </a:txBody>
+                  <a:tcPr marL="82296" marR="82296" marT="64008" marB="64008">
+                    <a:solidFill>
+                      <a:srgbClr val="FFFFFF"/>
+                    </a:solidFill>
+                  </a:tcPr>
+                </a:tc>
+                <a:tc>
+                  <a:txBody>
+                    <a:bodyPr wrap="none"/>
+                    <a:lstStyle/>
+                    <a:p>
+                      <a:pPr>
+                        <a:lnSpc>
+                          <a:spcPts val="1600"/>
+                        </a:lnSpc>
+                        <a:spcAft>
+                          <a:spcPts val="0"/>
+                        </a:spcAft>
+                        <a:defRPr sz="1200" b="0">
+                          <a:solidFill>
+                            <a:srgbClr val="21243A"/>
+                          </a:solidFill>
+                          <a:latin typeface="Arial"/>
+                        </a:defRPr>
+                      </a:pPr>
+                      <a:r>
+                        <a:t>Caveat: Visual match to a famous archival image is not proof of an unaltered copy;</a:t>
+                      </a:r>
+                    </a:p>
+                    <a:p>
+                      <a:pPr>
+                        <a:lnSpc>
+                          <a:spcPts val="1600"/>
+                        </a:lnSpc>
+                        <a:spcAft>
+                          <a:spcPts val="0"/>
+                        </a:spcAft>
+                        <a:defRPr sz="1200" b="0">
+                          <a:solidFill>
+                            <a:srgbClr val="21243A"/>
+                          </a:solidFill>
+                          <a:latin typeface="Arial"/>
+                        </a:defRPr>
+                      </a:pPr>
+                      <a:r>
+                        <a:t>subtle retouching, recoloring, or a high-fidelity regenerated replica cannot be</a:t>
+                      </a:r>
+                    </a:p>
+                    <a:p>
+                      <a:pPr>
+                        <a:lnSpc>
+                          <a:spcPts val="1600"/>
+                        </a:lnSpc>
+                        <a:spcAft>
+                          <a:spcPts val="0"/>
+                        </a:spcAft>
+                        <a:defRPr sz="1200" b="0">
+                          <a:solidFill>
+                            <a:srgbClr val="21243A"/>
+                          </a:solidFill>
+                          <a:latin typeface="Arial"/>
+                        </a:defRPr>
+                      </a:pPr>
+                      <a:r>
+                        <a:t>ruled out without comparison to the NASA source scan and metadata/provenance</a:t>
+                      </a:r>
+                    </a:p>
+                    <a:p>
+                      <a:pPr>
+                        <a:lnSpc>
+                          <a:spcPts val="1600"/>
+                        </a:lnSpc>
+                        <a:spcAft>
+                          <a:spcPts val="0"/>
+                        </a:spcAft>
+                        <a:defRPr sz="1200" b="0">
+                          <a:solidFill>
+                            <a:srgbClr val="21243A"/>
+                          </a:solidFill>
+                          <a:latin typeface="Arial"/>
+                        </a:defRPr>
+                      </a:pPr>
+                      <a:r>
+                        <a:t>checks.</a:t>
+                      </a:r>
+                    </a:p>
+                  </a:txBody>
+                  <a:tcPr marL="82296" marR="82296" marT="64008" marB="64008">
+                    <a:solidFill>
+                      <a:srgbClr val="FFFFFF"/>
                     </a:solidFill>
                   </a:tcPr>
                 </a:tc>
@@ -17056,7 +16394,7 @@
         </p:nvGraphicFramePr>
         <p:xfrm>
           <a:off x="365760" y="3797808"/>
-          <a:ext cx="8412479" cy="1162304"/>
+          <a:ext cx="8412479" cy="959103"/>
         </p:xfrm>
         <a:graphic>
           <a:graphicData uri="http://schemas.openxmlformats.org/drawingml/2006/table">
@@ -17068,7 +16406,7 @@
                 <a:gridCol w="2271369"/>
                 <a:gridCol w="6141110"/>
               </a:tblGrid>
-              <a:tr h="1162304">
+              <a:tr h="959103">
                 <a:tc>
                   <a:txBody>
                     <a:bodyPr wrap="none"/>
@@ -17119,83 +16457,64 @@
                         </a:defRPr>
                       </a:pPr>
                       <a:r>
-                        <a:t>synthetic likelihood 2/100; tells: Coherent coastlines of Africa, Madagascar and the</a:t>
-                      </a:r>
-                    </a:p>
-                    <a:p>
-                      <a:pPr>
-                        <a:lnSpc>
-                          <a:spcPts val="1600"/>
-                        </a:lnSpc>
-                        <a:spcAft>
-                          <a:spcPts val="0"/>
-                        </a:spcAft>
-                        <a:defRPr sz="1200" b="0">
-                          <a:solidFill>
-                            <a:srgbClr val="21243A"/>
-                          </a:solidFill>
-                          <a:latin typeface="Arial"/>
-                        </a:defRPr>
-                      </a:pPr>
-                      <a:r>
-                        <a:t>Arabian Peninsula, Irregular, finely detailed cloud systems with consistent</a:t>
-                      </a:r>
-                    </a:p>
-                    <a:p>
-                      <a:pPr>
-                        <a:lnSpc>
-                          <a:spcPts val="1600"/>
-                        </a:lnSpc>
-                        <a:spcAft>
-                          <a:spcPts val="0"/>
-                        </a:spcAft>
-                        <a:defRPr sz="1200" b="0">
-                          <a:solidFill>
-                            <a:srgbClr val="21243A"/>
-                          </a:solidFill>
-                          <a:latin typeface="Arial"/>
-                        </a:defRPr>
-                      </a:pPr>
-                      <a:r>
-                        <a:t>spherical foreshortening, Natural atmospheric haze and gradual shading around</a:t>
-                      </a:r>
-                    </a:p>
-                    <a:p>
-                      <a:pPr>
-                        <a:lnSpc>
-                          <a:spcPts val="1600"/>
-                        </a:lnSpc>
-                        <a:spcAft>
-                          <a:spcPts val="0"/>
-                        </a:spcAft>
-                        <a:defRPr sz="1200" b="0">
-                          <a:solidFill>
-                            <a:srgbClr val="21243A"/>
-                          </a:solidFill>
-                          <a:latin typeface="Arial"/>
-                        </a:defRPr>
-                      </a:pPr>
-                      <a:r>
-                        <a:t>Earth's limb, Fine photographic grain and slight color fringing along the globe</a:t>
-                      </a:r>
-                    </a:p>
-                    <a:p>
-                      <a:pPr>
-                        <a:lnSpc>
-                          <a:spcPts val="1600"/>
-                        </a:lnSpc>
-                        <a:spcAft>
-                          <a:spcPts val="0"/>
-                        </a:spcAft>
-                        <a:defRPr sz="1200" b="0">
-                          <a:solidFill>
-                            <a:srgbClr val="21243A"/>
-                          </a:solidFill>
-                          <a:latin typeface="Arial"/>
-                        </a:defRPr>
-                      </a:pPr>
-                      <a:r>
-                        <a:t>edge</a:t>
+                        <a:t>synthetic likelihood 2/100; tells: Coherent African, Arabian Peninsula, and</a:t>
+                      </a:r>
+                    </a:p>
+                    <a:p>
+                      <a:pPr>
+                        <a:lnSpc>
+                          <a:spcPts val="1600"/>
+                        </a:lnSpc>
+                        <a:spcAft>
+                          <a:spcPts val="0"/>
+                        </a:spcAft>
+                        <a:defRPr sz="1200" b="0">
+                          <a:solidFill>
+                            <a:srgbClr val="21243A"/>
+                          </a:solidFill>
+                          <a:latin typeface="Arial"/>
+                        </a:defRPr>
+                      </a:pPr>
+                      <a:r>
+                        <a:t>Madagascar coastlines, Intricate, nonrepeating cloud bands and storm spirals,</a:t>
+                      </a:r>
+                    </a:p>
+                    <a:p>
+                      <a:pPr>
+                        <a:lnSpc>
+                          <a:spcPts val="1600"/>
+                        </a:lnSpc>
+                        <a:spcAft>
+                          <a:spcPts val="0"/>
+                        </a:spcAft>
+                        <a:defRPr sz="1200" b="0">
+                          <a:solidFill>
+                            <a:srgbClr val="21243A"/>
+                          </a:solidFill>
+                          <a:latin typeface="Arial"/>
+                        </a:defRPr>
+                      </a:pPr>
+                      <a:r>
+                        <a:t>Consistent atmospheric haze and foreshortening toward Earth's limb, Fine grain</a:t>
+                      </a:r>
+                    </a:p>
+                    <a:p>
+                      <a:pPr>
+                        <a:lnSpc>
+                          <a:spcPts val="1600"/>
+                        </a:lnSpc>
+                        <a:spcAft>
+                          <a:spcPts val="0"/>
+                        </a:spcAft>
+                        <a:defRPr sz="1200" b="0">
+                          <a:solidFill>
+                            <a:srgbClr val="21243A"/>
+                          </a:solidFill>
+                          <a:latin typeface="Arial"/>
+                        </a:defRPr>
+                      </a:pPr>
+                      <a:r>
+                        <a:t>and slight softness consistent with a scanned photograph</a:t>
                       </a:r>
                     </a:p>
                   </a:txBody>
@@ -17219,7 +16538,7 @@
           <p:nvPr/>
         </p:nvGraphicFramePr>
         <p:xfrm>
-          <a:off x="365760" y="4960112"/>
+          <a:off x="365760" y="4756912"/>
           <a:ext cx="8412479" cy="349504"/>
         </p:xfrm>
         <a:graphic>
@@ -17283,7 +16602,7 @@
                         </a:defRPr>
                       </a:pPr>
                       <a:r>
-                        <a:t>Coherent coastlines of Africa, Madagascar and the Arabian Peninsula</a:t>
+                        <a:t>Coherent African, Arabian Peninsula, and Madagascar coastlines</a:t>
                       </a:r>
                     </a:p>
                   </a:txBody>
@@ -17307,7 +16626,7 @@
           <p:nvPr/>
         </p:nvGraphicFramePr>
         <p:xfrm>
-          <a:off x="365760" y="5309616"/>
+          <a:off x="365760" y="5106416"/>
           <a:ext cx="8412479" cy="349504"/>
         </p:xfrm>
         <a:graphic>
@@ -17371,13 +16690,101 @@
                         </a:defRPr>
                       </a:pPr>
                       <a:r>
-                        <a:t>Irregular, finely detailed cloud systems with consistent spherical foreshortening</a:t>
+                        <a:t>Intricate, nonrepeating cloud bands and storm spirals</a:t>
                       </a:r>
                     </a:p>
                   </a:txBody>
                   <a:tcPr marL="82296" marR="82296" marT="64008" marB="64008">
                     <a:solidFill>
                       <a:srgbClr val="F1F7F7"/>
+                    </a:solidFill>
+                  </a:tcPr>
+                </a:tc>
+              </a:tr>
+            </a:tbl>
+          </a:graphicData>
+        </a:graphic>
+      </p:graphicFrame>
+      <p:graphicFrame>
+        <p:nvGraphicFramePr>
+          <p:cNvPr id="16" name="Table 15"/>
+          <p:cNvGraphicFramePr>
+            <a:graphicFrameLocks noGrp="1"/>
+          </p:cNvGraphicFramePr>
+          <p:nvPr/>
+        </p:nvGraphicFramePr>
+        <p:xfrm>
+          <a:off x="365760" y="5455920"/>
+          <a:ext cx="8412479" cy="349504"/>
+        </p:xfrm>
+        <a:graphic>
+          <a:graphicData uri="http://schemas.openxmlformats.org/drawingml/2006/table">
+            <a:tbl>
+              <a:tblPr firstRow="1" bandRow="1">
+                <a:tableStyleId>{5C22544A-7EE6-4342-B048-85BDC9FD1C3A}</a:tableStyleId>
+              </a:tblPr>
+              <a:tblGrid>
+                <a:gridCol w="2271369"/>
+                <a:gridCol w="6141110"/>
+              </a:tblGrid>
+              <a:tr h="349504">
+                <a:tc>
+                  <a:txBody>
+                    <a:bodyPr wrap="none"/>
+                    <a:lstStyle/>
+                    <a:p>
+                      <a:pPr>
+                        <a:lnSpc>
+                          <a:spcPts val="1600"/>
+                        </a:lnSpc>
+                        <a:spcAft>
+                          <a:spcPts val="0"/>
+                        </a:spcAft>
+                        <a:defRPr sz="1200" b="0">
+                          <a:solidFill>
+                            <a:srgbClr val="21243A"/>
+                          </a:solidFill>
+                          <a:latin typeface="Arial"/>
+                        </a:defRPr>
+                      </a:pPr>
+                      <a:r>
+                        <a:t>Evidence 3</a:t>
+                      </a:r>
+                    </a:p>
+                  </a:txBody>
+                  <a:tcPr marL="82296" marR="82296" marT="64008" marB="64008">
+                    <a:solidFill>
+                      <a:srgbClr val="FFFFFF"/>
+                    </a:solidFill>
+                  </a:tcPr>
+                </a:tc>
+                <a:tc>
+                  <a:txBody>
+                    <a:bodyPr wrap="none"/>
+                    <a:lstStyle/>
+                    <a:p>
+                      <a:pPr>
+                        <a:lnSpc>
+                          <a:spcPts val="1600"/>
+                        </a:lnSpc>
+                        <a:spcAft>
+                          <a:spcPts val="0"/>
+                        </a:spcAft>
+                        <a:defRPr sz="1200" b="0">
+                          <a:solidFill>
+                            <a:srgbClr val="21243A"/>
+                          </a:solidFill>
+                          <a:latin typeface="Arial"/>
+                        </a:defRPr>
+                      </a:pPr>
+                      <a:r>
+                        <a:t>Consistent atmospheric haze and foreshortening toward Earth's limb</a:t>
+                      </a:r>
+                    </a:p>
+                  </a:txBody>
+                  <a:tcPr marL="82296" marR="82296" marT="64008" marB="64008">
+                    <a:solidFill>
+                      <a:srgbClr val="FFFFFF"/>
                     </a:solidFill>
                   </a:tcPr>
                 </a:tc>
@@ -17703,43 +17110,43 @@
                         </a:defRPr>
                       </a:pPr>
                       <a:r>
-                        <a:t>Evidence 3</a:t>
-                      </a:r>
-                    </a:p>
-                  </a:txBody>
-                  <a:tcPr marL="82296" marR="82296" marT="64008" marB="64008">
-                    <a:solidFill>
-                      <a:srgbClr val="FFFFFF"/>
-                    </a:solidFill>
-                  </a:tcPr>
-                </a:tc>
-                <a:tc>
-                  <a:txBody>
-                    <a:bodyPr wrap="none"/>
-                    <a:lstStyle/>
-                    <a:p>
-                      <a:pPr>
-                        <a:lnSpc>
-                          <a:spcPts val="1600"/>
-                        </a:lnSpc>
-                        <a:spcAft>
-                          <a:spcPts val="0"/>
-                        </a:spcAft>
-                        <a:defRPr sz="1200" b="0">
-                          <a:solidFill>
-                            <a:srgbClr val="21243A"/>
-                          </a:solidFill>
-                          <a:latin typeface="Arial"/>
-                        </a:defRPr>
-                      </a:pPr>
-                      <a:r>
-                        <a:t>Natural atmospheric haze and gradual shading around Earth's limb</a:t>
-                      </a:r>
-                    </a:p>
-                  </a:txBody>
-                  <a:tcPr marL="82296" marR="82296" marT="64008" marB="64008">
-                    <a:solidFill>
-                      <a:srgbClr val="FFFFFF"/>
+                        <a:t>Evidence 4</a:t>
+                      </a:r>
+                    </a:p>
+                  </a:txBody>
+                  <a:tcPr marL="82296" marR="82296" marT="64008" marB="64008">
+                    <a:solidFill>
+                      <a:srgbClr val="F1F7F7"/>
+                    </a:solidFill>
+                  </a:tcPr>
+                </a:tc>
+                <a:tc>
+                  <a:txBody>
+                    <a:bodyPr wrap="none"/>
+                    <a:lstStyle/>
+                    <a:p>
+                      <a:pPr>
+                        <a:lnSpc>
+                          <a:spcPts val="1600"/>
+                        </a:lnSpc>
+                        <a:spcAft>
+                          <a:spcPts val="0"/>
+                        </a:spcAft>
+                        <a:defRPr sz="1200" b="0">
+                          <a:solidFill>
+                            <a:srgbClr val="21243A"/>
+                          </a:solidFill>
+                          <a:latin typeface="Arial"/>
+                        </a:defRPr>
+                      </a:pPr>
+                      <a:r>
+                        <a:t>Fine grain and slight softness consistent with a scanned photograph</a:t>
+                      </a:r>
+                    </a:p>
+                  </a:txBody>
+                  <a:tcPr marL="82296" marR="82296" marT="64008" marB="64008">
+                    <a:solidFill>
+                      <a:srgbClr val="F1F7F7"/>
                     </a:solidFill>
                   </a:tcPr>
                 </a:tc>
@@ -17791,43 +17198,43 @@
                         </a:defRPr>
                       </a:pPr>
                       <a:r>
-                        <a:t>Evidence 4</a:t>
-                      </a:r>
-                    </a:p>
-                  </a:txBody>
-                  <a:tcPr marL="82296" marR="82296" marT="64008" marB="64008">
-                    <a:solidFill>
-                      <a:srgbClr val="F1F7F7"/>
-                    </a:solidFill>
-                  </a:tcPr>
-                </a:tc>
-                <a:tc>
-                  <a:txBody>
-                    <a:bodyPr wrap="none"/>
-                    <a:lstStyle/>
-                    <a:p>
-                      <a:pPr>
-                        <a:lnSpc>
-                          <a:spcPts val="1600"/>
-                        </a:lnSpc>
-                        <a:spcAft>
-                          <a:spcPts val="0"/>
-                        </a:spcAft>
-                        <a:defRPr sz="1200" b="0">
-                          <a:solidFill>
-                            <a:srgbClr val="21243A"/>
-                          </a:solidFill>
-                          <a:latin typeface="Arial"/>
-                        </a:defRPr>
-                      </a:pPr>
-                      <a:r>
-                        <a:t>Fine photographic grain and slight color fringing along the globe edge</a:t>
-                      </a:r>
-                    </a:p>
-                  </a:txBody>
-                  <a:tcPr marL="82296" marR="82296" marT="64008" marB="64008">
-                    <a:solidFill>
-                      <a:srgbClr val="F1F7F7"/>
+                        <a:t>Evidence 5</a:t>
+                      </a:r>
+                    </a:p>
+                  </a:txBody>
+                  <a:tcPr marL="82296" marR="82296" marT="64008" marB="64008">
+                    <a:solidFill>
+                      <a:srgbClr val="FFFFFF"/>
+                    </a:solidFill>
+                  </a:tcPr>
+                </a:tc>
+                <a:tc>
+                  <a:txBody>
+                    <a:bodyPr wrap="none"/>
+                    <a:lstStyle/>
+                    <a:p>
+                      <a:pPr>
+                        <a:lnSpc>
+                          <a:spcPts val="1600"/>
+                        </a:lnSpc>
+                        <a:spcAft>
+                          <a:spcPts val="0"/>
+                        </a:spcAft>
+                        <a:defRPr sz="1200" b="0">
+                          <a:solidFill>
+                            <a:srgbClr val="21243A"/>
+                          </a:solidFill>
+                          <a:latin typeface="Arial"/>
+                        </a:defRPr>
+                      </a:pPr>
+                      <a:r>
+                        <a:t>Composition closely resembles the historical Blue Marble photograph</a:t>
+                      </a:r>
+                    </a:p>
+                  </a:txBody>
+                  <a:tcPr marL="82296" marR="82296" marT="64008" marB="64008">
+                    <a:solidFill>
+                      <a:srgbClr val="FFFFFF"/>
                     </a:solidFill>
                   </a:tcPr>
                 </a:tc>
@@ -17879,62 +17286,62 @@
                         </a:defRPr>
                       </a:pPr>
                       <a:r>
-                        <a:t>Evidence 5</a:t>
-                      </a:r>
-                    </a:p>
-                  </a:txBody>
-                  <a:tcPr marL="82296" marR="82296" marT="64008" marB="64008">
-                    <a:solidFill>
-                      <a:srgbClr val="FFFFFF"/>
-                    </a:solidFill>
-                  </a:tcPr>
-                </a:tc>
-                <a:tc>
-                  <a:txBody>
-                    <a:bodyPr wrap="none"/>
-                    <a:lstStyle/>
-                    <a:p>
-                      <a:pPr>
-                        <a:lnSpc>
-                          <a:spcPts val="1600"/>
-                        </a:lnSpc>
-                        <a:spcAft>
-                          <a:spcPts val="0"/>
-                        </a:spcAft>
-                        <a:defRPr sz="1200" b="0">
-                          <a:solidFill>
-                            <a:srgbClr val="21243A"/>
-                          </a:solidFill>
-                          <a:latin typeface="Arial"/>
-                        </a:defRPr>
-                      </a:pPr>
-                      <a:r>
-                        <a:t>Caveat: Resembles the historical Blue Marble photograph; source-file comparison</a:t>
-                      </a:r>
-                    </a:p>
-                    <a:p>
-                      <a:pPr>
-                        <a:lnSpc>
-                          <a:spcPts val="1600"/>
-                        </a:lnSpc>
-                        <a:spcAft>
-                          <a:spcPts val="0"/>
-                        </a:spcAft>
-                        <a:defRPr sz="1200" b="0">
-                          <a:solidFill>
-                            <a:srgbClr val="21243A"/>
-                          </a:solidFill>
-                          <a:latin typeface="Arial"/>
-                        </a:defRPr>
-                      </a:pPr>
-                      <a:r>
-                        <a:t>is needed to establish provenance and exclude subtle edits.</a:t>
-                      </a:r>
-                    </a:p>
-                  </a:txBody>
-                  <a:tcPr marL="82296" marR="82296" marT="64008" marB="64008">
-                    <a:solidFill>
-                      <a:srgbClr val="FFFFFF"/>
+                        <a:t>Evidence 6</a:t>
+                      </a:r>
+                    </a:p>
+                  </a:txBody>
+                  <a:tcPr marL="82296" marR="82296" marT="64008" marB="64008">
+                    <a:solidFill>
+                      <a:srgbClr val="F1F7F7"/>
+                    </a:solidFill>
+                  </a:tcPr>
+                </a:tc>
+                <a:tc>
+                  <a:txBody>
+                    <a:bodyPr wrap="none"/>
+                    <a:lstStyle/>
+                    <a:p>
+                      <a:pPr>
+                        <a:lnSpc>
+                          <a:spcPts val="1600"/>
+                        </a:lnSpc>
+                        <a:spcAft>
+                          <a:spcPts val="0"/>
+                        </a:spcAft>
+                        <a:defRPr sz="1200" b="0">
+                          <a:solidFill>
+                            <a:srgbClr val="21243A"/>
+                          </a:solidFill>
+                          <a:latin typeface="Arial"/>
+                        </a:defRPr>
+                      </a:pPr>
+                      <a:r>
+                        <a:t>Caveat: Visual resemblance cannot establish provenance; compare with the</a:t>
+                      </a:r>
+                    </a:p>
+                    <a:p>
+                      <a:pPr>
+                        <a:lnSpc>
+                          <a:spcPts val="1600"/>
+                        </a:lnSpc>
+                        <a:spcAft>
+                          <a:spcPts val="0"/>
+                        </a:spcAft>
+                        <a:defRPr sz="1200" b="0">
+                          <a:solidFill>
+                            <a:srgbClr val="21243A"/>
+                          </a:solidFill>
+                          <a:latin typeface="Arial"/>
+                        </a:defRPr>
+                      </a:pPr>
+                      <a:r>
+                        <a:t>archival original to check for subsequent edits.</a:t>
+                      </a:r>
+                    </a:p>
+                  </a:txBody>
+                  <a:tcPr marL="82296" marR="82296" marT="64008" marB="64008">
+                    <a:solidFill>
+                      <a:srgbClr val="F1F7F7"/>
                     </a:solidFill>
                   </a:tcPr>
                 </a:tc>
@@ -18642,7 +18049,7 @@
                         </a:defRPr>
                       </a:pPr>
                       <a:r>
-                        <a:t>high</a:t>
+                        <a:t>medium</a:t>
                       </a:r>
                     </a:p>
                   </a:txBody>
@@ -18818,45 +18225,45 @@
                         </a:defRPr>
                       </a:pPr>
                       <a:r>
-                        <a:t>synthetic likelihood 15/100; tells: authentic Apollo 17 'Blue Marble' photograph,</a:t>
-                      </a:r>
-                    </a:p>
-                    <a:p>
-                      <a:pPr>
-                        <a:lnSpc>
-                          <a:spcPts val="1600"/>
-                        </a:lnSpc>
-                        <a:spcAft>
-                          <a:spcPts val="0"/>
-                        </a:spcAft>
-                        <a:defRPr sz="1200" b="0">
-                          <a:solidFill>
-                            <a:srgbClr val="21243A"/>
-                          </a:solidFill>
-                          <a:latin typeface="Arial"/>
-                        </a:defRPr>
-                      </a:pPr>
-                      <a:r>
-                        <a:t>natural film grain structure, consistent atmospheric limb glow, accurate</a:t>
-                      </a:r>
-                    </a:p>
-                    <a:p>
-                      <a:pPr>
-                        <a:lnSpc>
-                          <a:spcPts val="1600"/>
-                        </a:lnSpc>
-                        <a:spcAft>
-                          <a:spcPts val="0"/>
-                        </a:spcAft>
-                        <a:defRPr sz="1200" b="0">
-                          <a:solidFill>
-                            <a:srgbClr val="21243A"/>
-                          </a:solidFill>
-                          <a:latin typeface="Arial"/>
-                        </a:defRPr>
-                      </a:pPr>
-                      <a:r>
-                        <a:t>meteorological cloud swirls</a:t>
+                        <a:t>synthetic likelihood 25/100; tells: authentic film grain, consistent atmospheric limb</a:t>
+                      </a:r>
+                    </a:p>
+                    <a:p>
+                      <a:pPr>
+                        <a:lnSpc>
+                          <a:spcPts val="1600"/>
+                        </a:lnSpc>
+                        <a:spcAft>
+                          <a:spcPts val="0"/>
+                        </a:spcAft>
+                        <a:defRPr sz="1200" b="0">
+                          <a:solidFill>
+                            <a:srgbClr val="21243A"/>
+                          </a:solidFill>
+                          <a:latin typeface="Arial"/>
+                        </a:defRPr>
+                      </a:pPr>
+                      <a:r>
+                        <a:t>scatter, historically documented cloud formations, natural optical sensor</a:t>
+                      </a:r>
+                    </a:p>
+                    <a:p>
+                      <a:pPr>
+                        <a:lnSpc>
+                          <a:spcPts val="1600"/>
+                        </a:lnSpc>
+                        <a:spcAft>
+                          <a:spcPts val="0"/>
+                        </a:spcAft>
+                        <a:defRPr sz="1200" b="0">
+                          <a:solidFill>
+                            <a:srgbClr val="21243A"/>
+                          </a:solidFill>
+                          <a:latin typeface="Arial"/>
+                        </a:defRPr>
+                      </a:pPr>
+                      <a:r>
+                        <a:t>characteristics</a:t>
                       </a:r>
                     </a:p>
                   </a:txBody>
@@ -18944,7 +18351,7 @@
                         </a:defRPr>
                       </a:pPr>
                       <a:r>
-                        <a:t>Authentic Apollo 17 'Blue Marble' photograph</a:t>
+                        <a:t>Authentic film grain</a:t>
                       </a:r>
                     </a:p>
                   </a:txBody>
@@ -19032,7 +18439,7 @@
                         </a:defRPr>
                       </a:pPr>
                       <a:r>
-                        <a:t>Natural film grain structure</a:t>
+                        <a:t>Consistent atmospheric limb scatter</a:t>
                       </a:r>
                     </a:p>
                   </a:txBody>
@@ -19120,7 +18527,7 @@
                         </a:defRPr>
                       </a:pPr>
                       <a:r>
-                        <a:t>Consistent atmospheric limb glow</a:t>
+                        <a:t>Historically documented cloud formations</a:t>
                       </a:r>
                     </a:p>
                   </a:txBody>
@@ -19482,7 +18889,7 @@
                         </a:defRPr>
                       </a:pPr>
                       <a:r>
-                        <a:t>Accurate meteorological cloud swirls</a:t>
+                        <a:t>Natural optical sensor characteristics</a:t>
                       </a:r>
                     </a:p>
                   </a:txBody>
@@ -19570,26 +18977,26 @@
                         </a:defRPr>
                       </a:pPr>
                       <a:r>
-                        <a:t>Caveat: High-profile historic images are frequently duplicated, cropped, or</a:t>
-                      </a:r>
-                    </a:p>
-                    <a:p>
-                      <a:pPr>
-                        <a:lnSpc>
-                          <a:spcPts val="1600"/>
-                        </a:lnSpc>
-                        <a:spcAft>
-                          <a:spcPts val="0"/>
-                        </a:spcAft>
-                        <a:defRPr sz="1200" b="0">
-                          <a:solidFill>
-                            <a:srgbClr val="21243A"/>
-                          </a:solidFill>
-                          <a:latin typeface="Arial"/>
-                        </a:defRPr>
-                      </a:pPr>
-                      <a:r>
-                        <a:t>color-adjusted across digital archives.</a:t>
+                        <a:t>Caveat: High-profile historical images can be digitally remastered or simulated by</a:t>
+                      </a:r>
+                    </a:p>
+                    <a:p>
+                      <a:pPr>
+                        <a:lnSpc>
+                          <a:spcPts val="1600"/>
+                        </a:lnSpc>
+                        <a:spcAft>
+                          <a:spcPts val="0"/>
+                        </a:spcAft>
+                        <a:defRPr sz="1200" b="0">
+                          <a:solidFill>
+                            <a:srgbClr val="21243A"/>
+                          </a:solidFill>
+                          <a:latin typeface="Arial"/>
+                        </a:defRPr>
+                      </a:pPr>
+                      <a:r>
+                        <a:t>generative models.</a:t>
                       </a:r>
                     </a:p>
                   </a:txBody>

</xml_diff>